<commit_message>
feat: update README, REPORT.md, and presentation for submission
README.md: restructured with accurate test count (15), fixed mlflow ui command, removed empty section, added CLI entry point, docker-compose usage, demo notebook reference.

REPORT.md: new comprehensive report with executive summary, assignment objectives table, evaluation criteria evidence, full 6-run hyperparameter grid, 3-split performance table, optimized benchmark, failure analysis, prioritized recommendations, MLOps table, and conclusion.

presentation.pptx: 8-slide deck with clean narrative flow (problem -> dataset -> architecture -> results -> optimization -> failure analysis -> MLOps -> recommendations). Dark navy theme, grouped by impact.

make_pptx.py: supports command-line output path argument.

.gitignore: add ~$*.pptx to exclude Office lock files.
</commit_message>
<xml_diff>
--- a/presentation.pptx
+++ b/presentation.pptx
@@ -3105,14 +3105,57 @@
       <p:grpSpPr/>
       <p:sp>
         <p:nvSpPr>
-          <p:cNvPr id="2" name="TextBox 1"/>
+          <p:cNvPr id="2" name="Rectangle 1"/>
+          <p:cNvSpPr/>
+          <p:nvPr/>
+        </p:nvSpPr>
+        <p:spPr>
+          <a:xfrm>
+            <a:off x="0" y="2926080"/>
+            <a:ext cx="12191695" cy="36576"/>
+          </a:xfrm>
+          <a:prstGeom prst="rect">
+            <a:avLst/>
+          </a:prstGeom>
+          <a:solidFill>
+            <a:srgbClr val="2E86AB"/>
+          </a:solidFill>
+          <a:ln>
+            <a:noFill/>
+          </a:ln>
+        </p:spPr>
+        <p:style>
+          <a:lnRef idx="1">
+            <a:schemeClr val="accent1"/>
+          </a:lnRef>
+          <a:fillRef idx="3">
+            <a:schemeClr val="accent1"/>
+          </a:fillRef>
+          <a:effectRef idx="2">
+            <a:schemeClr val="accent1"/>
+          </a:effectRef>
+          <a:fontRef idx="minor">
+            <a:schemeClr val="lt1"/>
+          </a:fontRef>
+        </p:style>
+        <p:txBody>
+          <a:bodyPr rtlCol="0" anchor="ctr"/>
+          <a:lstStyle/>
+          <a:p>
+            <a:pPr algn="ctr"/>
+          </a:p>
+        </p:txBody>
+      </p:sp>
+      <p:sp>
+        <p:nvSpPr>
+          <p:cNvPr id="3" name="TextBox 2"/>
           <p:cNvSpPr txBox="1"/>
           <p:nvPr/>
         </p:nvSpPr>
         <p:spPr>
           <a:xfrm>
-            <a:off x="914400" y="1828800"/>
-            <a:ext cx="10058400" cy="1371600"/>
+            <a:off x="914400" y="1371600"/>
+            <a:ext cx="10362895" cy="731520"/>
           </a:xfrm>
           <a:prstGeom prst="rect">
             <a:avLst/>
@@ -3140,14 +3183,14 @@
       </p:sp>
       <p:sp>
         <p:nvSpPr>
-          <p:cNvPr id="3" name="TextBox 2"/>
+          <p:cNvPr id="4" name="TextBox 3"/>
           <p:cNvSpPr txBox="1"/>
           <p:nvPr/>
         </p:nvSpPr>
         <p:spPr>
           <a:xfrm>
-            <a:off x="914400" y="3840480"/>
-            <a:ext cx="10058400" cy="914400"/>
+            <a:off x="914400" y="3291840"/>
+            <a:ext cx="10362895" cy="731520"/>
           </a:xfrm>
           <a:prstGeom prst="rect">
             <a:avLst/>
@@ -3161,28 +3204,28 @@
           <a:lstStyle/>
           <a:p>
             <a:pPr algn="ctr">
-              <a:defRPr sz="1800">
+              <a:defRPr sz="1800" b="1">
                 <a:solidFill>
                   <a:srgbClr val="2E86AB"/>
                 </a:solidFill>
               </a:defRPr>
             </a:pPr>
             <a:r>
-              <a:t>U-Net + ResNet34 | Sentinel-2 Satellite Imagery | PyTorch + ONNX</a:t>
-            </a:r>
-          </a:p>
-        </p:txBody>
-      </p:sp>
-      <p:sp>
-        <p:nvSpPr>
-          <p:cNvPr id="4" name="TextBox 3"/>
+              <a:t>U-Net + ResNet34  |  Sentinel-2 Satellite Imagery  |  PyTorch + ONNX</a:t>
+            </a:r>
+          </a:p>
+        </p:txBody>
+      </p:sp>
+      <p:sp>
+        <p:nvSpPr>
+          <p:cNvPr id="5" name="TextBox 4"/>
           <p:cNvSpPr txBox="1"/>
           <p:nvPr/>
         </p:nvSpPr>
         <p:spPr>
           <a:xfrm>
-            <a:off x="914400" y="4754880"/>
-            <a:ext cx="10058400" cy="914400"/>
+            <a:off x="914400" y="5029200"/>
+            <a:ext cx="10362895" cy="731520"/>
           </a:xfrm>
           <a:prstGeom prst="rect">
             <a:avLst/>
@@ -3196,9 +3239,9 @@
           <a:lstStyle/>
           <a:p>
             <a:pPr algn="ctr">
-              <a:defRPr sz="2000">
-                <a:solidFill>
-                  <a:srgbClr val="2E86AB"/>
+              <a:defRPr sz="2000" b="0">
+                <a:solidFill>
+                  <a:srgbClr val="BBBBBB"/>
                 </a:solidFill>
               </a:defRPr>
             </a:pPr>
@@ -3219,6 +3262,14 @@
 <file path=ppt/slides/slide2.xml><?xml version="1.0" encoding="utf-8"?>
 <p:sld xmlns:a="http://schemas.openxmlformats.org/drawingml/2006/main" xmlns:p="http://schemas.openxmlformats.org/presentationml/2006/main" xmlns:r="http://schemas.openxmlformats.org/officeDocument/2006/relationships">
   <p:cSld>
+    <p:bg>
+      <p:bgPr>
+        <a:solidFill>
+          <a:srgbClr val="F5F7FA"/>
+        </a:solidFill>
+        <a:effectLst/>
+      </p:bgPr>
+    </p:bg>
     <p:spTree>
       <p:nvGrpSpPr>
         <p:cNvPr id="1" name=""/>
@@ -3243,20 +3294,20 @@
           <a:noFill/>
         </p:spPr>
         <p:txBody>
-          <a:bodyPr wrap="none">
+          <a:bodyPr wrap="square">
             <a:spAutoFit/>
           </a:bodyPr>
           <a:lstStyle/>
           <a:p>
-            <a:pPr>
+            <a:pPr algn="ctr">
               <a:defRPr sz="2800" b="1">
                 <a:solidFill>
-                  <a:srgbClr val="1B2A4A"/>
+                  <a:srgbClr val="333333"/>
                 </a:solidFill>
               </a:defRPr>
             </a:pPr>
             <a:r>
-              <a:t>Dataset: Satellite Images of Water Bodies</a:t>
+              <a:t>Problem: Segment Water from Satellite Imagery</a:t>
             </a:r>
           </a:p>
         </p:txBody>
@@ -3269,7 +3320,7 @@
         </p:nvSpPr>
         <p:spPr>
           <a:xfrm>
-            <a:off x="731520" y="1371600"/>
+            <a:off x="731520" y="1280160"/>
             <a:ext cx="10515600" cy="4572000"/>
           </a:xfrm>
           <a:prstGeom prst="rect">
@@ -3285,7 +3336,7 @@
           <a:p>
             <a:pPr>
               <a:spcAft>
-                <a:spcPts val="800"/>
+                <a:spcPts val="600"/>
               </a:spcAft>
               <a:defRPr sz="1600">
                 <a:solidFill>
@@ -3294,13 +3345,13 @@
               </a:defRPr>
             </a:pPr>
             <a:r>
-              <a:t>Source: Kaggle, 2,841 RGB image-mask pairs from Sentinel-2</a:t>
+              <a:t>2,841 Sentinel-2 images with binary water/non-water masks (~2009x2007 px)</a:t>
             </a:r>
           </a:p>
           <a:p>
             <a:pPr>
               <a:spcAft>
-                <a:spcPts val="800"/>
+                <a:spcPts val="600"/>
               </a:spcAft>
               <a:defRPr sz="1600">
                 <a:solidFill>
@@ -3309,28 +3360,58 @@
               </a:defRPr>
             </a:pPr>
             <a:r>
-              <a:t>Resolution: ~2009 x 2007 pixels, sourced from Bands 8 (NIR) and 3</a:t>
+              <a:t>Key challenges:</a:t>
             </a:r>
           </a:p>
           <a:p>
             <a:pPr lvl="1">
               <a:spcAft>
-                <a:spcPts val="800"/>
+                <a:spcPts val="600"/>
               </a:spcAft>
               <a:defRPr sz="1400">
                 <a:solidFill>
-                  <a:srgbClr val="606060"/>
+                  <a:srgbClr val="808080"/>
                 </a:solidFill>
               </a:defRPr>
             </a:pPr>
             <a:r>
-              <a:t>  Masks derived via NDWI thresholding</a:t>
+              <a:t>  Class imbalance: 7.6% water vs 92.4% non-water pixels</a:t>
+            </a:r>
+          </a:p>
+          <a:p>
+            <a:pPr lvl="1">
+              <a:spcAft>
+                <a:spcPts val="600"/>
+              </a:spcAft>
+              <a:defRPr sz="1400">
+                <a:solidFill>
+                  <a:srgbClr val="808080"/>
+                </a:solidFill>
+              </a:defRPr>
+            </a:pPr>
+            <a:r>
+              <a:t>  JPEG artifacts: 96% of masks have compression noise (values 1-199)</a:t>
+            </a:r>
+          </a:p>
+          <a:p>
+            <a:pPr lvl="1">
+              <a:spcAft>
+                <a:spcPts val="600"/>
+              </a:spcAft>
+              <a:defRPr sz="1400">
+                <a:solidFill>
+                  <a:srgbClr val="808080"/>
+                </a:solidFill>
+              </a:defRPr>
+            </a:pPr>
+            <a:r>
+              <a:t>  RGB-only input -- no NIR band to distinguish water from shadow</a:t>
             </a:r>
           </a:p>
           <a:p>
             <a:pPr>
               <a:spcAft>
-                <a:spcPts val="800"/>
+                <a:spcPts val="600"/>
               </a:spcAft>
               <a:defRPr sz="1600">
                 <a:solidFill>
@@ -3338,11 +3419,14 @@
                 </a:solidFill>
               </a:defRPr>
             </a:pPr>
+            <a:r>
+              <a:t>Data split: 70% train (1,989), 15% val (426), 15% test (426)</a:t>
+            </a:r>
           </a:p>
           <a:p>
             <a:pPr>
               <a:spcAft>
-                <a:spcPts val="800"/>
+                <a:spcPts val="600"/>
               </a:spcAft>
               <a:defRPr sz="1600">
                 <a:solidFill>
@@ -3351,94 +3435,7 @@
               </a:defRPr>
             </a:pPr>
             <a:r>
-              <a:t>Key Challenges:</a:t>
-            </a:r>
-          </a:p>
-          <a:p>
-            <a:pPr lvl="1">
-              <a:spcAft>
-                <a:spcPts val="800"/>
-              </a:spcAft>
-              <a:defRPr sz="1400">
-                <a:solidFill>
-                  <a:srgbClr val="606060"/>
-                </a:solidFill>
-              </a:defRPr>
-            </a:pPr>
-            <a:r>
-              <a:t>  Class imbalance: water = 7.6%, non-water = 92.4%</a:t>
-            </a:r>
-          </a:p>
-          <a:p>
-            <a:pPr lvl="1">
-              <a:spcAft>
-                <a:spcPts val="800"/>
-              </a:spcAft>
-              <a:defRPr sz="1400">
-                <a:solidFill>
-                  <a:srgbClr val="606060"/>
-                </a:solidFill>
-              </a:defRPr>
-            </a:pPr>
-            <a:r>
-              <a:t>  JPEG artifacts in masks: values 1-199 from compression</a:t>
-            </a:r>
-          </a:p>
-          <a:p>
-            <a:pPr lvl="1">
-              <a:spcAft>
-                <a:spcPts val="800"/>
-              </a:spcAft>
-              <a:defRPr sz="1400">
-                <a:solidFill>
-                  <a:srgbClr val="606060"/>
-                </a:solidFill>
-              </a:defRPr>
-            </a:pPr>
-            <a:r>
-              <a:t>  Spatial diversity: coastlines, rivers, lakes, wetlands</a:t>
-            </a:r>
-          </a:p>
-          <a:p>
-            <a:pPr>
-              <a:spcAft>
-                <a:spcPts val="800"/>
-              </a:spcAft>
-              <a:defRPr sz="1600">
-                <a:solidFill>
-                  <a:srgbClr val="333333"/>
-                </a:solidFill>
-              </a:defRPr>
-            </a:pPr>
-          </a:p>
-          <a:p>
-            <a:pPr>
-              <a:spcAft>
-                <a:spcPts val="800"/>
-              </a:spcAft>
-              <a:defRPr sz="1600">
-                <a:solidFill>
-                  <a:srgbClr val="333333"/>
-                </a:solidFill>
-              </a:defRPr>
-            </a:pPr>
-            <a:r>
-              <a:t>Preprocessing: resize to 256x256, mask threshold &gt;200,</a:t>
-            </a:r>
-          </a:p>
-          <a:p>
-            <a:pPr lvl="1">
-              <a:spcAft>
-                <a:spcPts val="800"/>
-              </a:spcAft>
-              <a:defRPr sz="1400">
-                <a:solidFill>
-                  <a:srgbClr val="606060"/>
-                </a:solidFill>
-              </a:defRPr>
-            </a:pPr>
-            <a:r>
-              <a:t>  ImageNet normalization, augmentations (flip, rotate, color jitter)</a:t>
+              <a:t>Preprocessing: resize 256x256, ImageNet norm, aug (flip + rotate + color)</a:t>
             </a:r>
           </a:p>
         </p:txBody>
@@ -3454,6 +3451,14 @@
 <file path=ppt/slides/slide3.xml><?xml version="1.0" encoding="utf-8"?>
 <p:sld xmlns:a="http://schemas.openxmlformats.org/drawingml/2006/main" xmlns:p="http://schemas.openxmlformats.org/presentationml/2006/main" xmlns:r="http://schemas.openxmlformats.org/officeDocument/2006/relationships">
   <p:cSld>
+    <p:bg>
+      <p:bgPr>
+        <a:solidFill>
+          <a:srgbClr val="F5F7FA"/>
+        </a:solidFill>
+        <a:effectLst/>
+      </p:bgPr>
+    </p:bg>
     <p:spTree>
       <p:nvGrpSpPr>
         <p:cNvPr id="1" name=""/>
@@ -3478,20 +3483,20 @@
           <a:noFill/>
         </p:spPr>
         <p:txBody>
-          <a:bodyPr wrap="none">
+          <a:bodyPr wrap="square">
             <a:spAutoFit/>
           </a:bodyPr>
           <a:lstStyle/>
           <a:p>
-            <a:pPr>
+            <a:pPr algn="ctr">
               <a:defRPr sz="2800" b="1">
                 <a:solidFill>
-                  <a:srgbClr val="1B2A4A"/>
+                  <a:srgbClr val="333333"/>
                 </a:solidFill>
               </a:defRPr>
             </a:pPr>
             <a:r>
-              <a:t>Model Architecture: U-Net + ResNet34</a:t>
+              <a:t>Model: U-Net + ResNet34</a:t>
             </a:r>
           </a:p>
         </p:txBody>
@@ -3504,7 +3509,7 @@
         </p:nvSpPr>
         <p:spPr>
           <a:xfrm>
-            <a:off x="731520" y="1371600"/>
+            <a:off x="731520" y="1280160"/>
             <a:ext cx="10515600" cy="4572000"/>
           </a:xfrm>
           <a:prstGeom prst="rect">
@@ -3520,7 +3525,7 @@
           <a:p>
             <a:pPr>
               <a:spcAft>
-                <a:spcPts val="800"/>
+                <a:spcPts val="600"/>
               </a:spcAft>
               <a:defRPr sz="1600">
                 <a:solidFill>
@@ -3529,13 +3534,13 @@
               </a:defRPr>
             </a:pPr>
             <a:r>
-              <a:t>Encoder: ResNet34 pretrained on ImageNet (21M params)</a:t>
+              <a:t>Encoder: ResNet34 (21M params), pretrained on ImageNet</a:t>
             </a:r>
           </a:p>
           <a:p>
             <a:pPr>
               <a:spcAft>
-                <a:spcPts val="800"/>
+                <a:spcPts val="600"/>
               </a:spcAft>
               <a:defRPr sz="1600">
                 <a:solidFill>
@@ -3544,13 +3549,13 @@
               </a:defRPr>
             </a:pPr>
             <a:r>
-              <a:t>Decoder: U-Net with skip connections</a:t>
+              <a:t>Decoder: U-Net with spatial skip connections</a:t>
             </a:r>
           </a:p>
           <a:p>
             <a:pPr>
               <a:spcAft>
-                <a:spcPts val="800"/>
+                <a:spcPts val="600"/>
               </a:spcAft>
               <a:defRPr sz="1600">
                 <a:solidFill>
@@ -3559,13 +3564,13 @@
               </a:defRPr>
             </a:pPr>
             <a:r>
-              <a:t>Output: Single-channel logit, sigmoid -&gt; binary mask</a:t>
+              <a:t>Loss: 0.5 x BCE + 0.5 x Dice (hybrid pixel + overlap optimization)</a:t>
             </a:r>
           </a:p>
           <a:p>
             <a:pPr>
               <a:spcAft>
-                <a:spcPts val="800"/>
+                <a:spcPts val="600"/>
               </a:spcAft>
               <a:defRPr sz="1600">
                 <a:solidFill>
@@ -3573,11 +3578,14 @@
                 </a:solidFill>
               </a:defRPr>
             </a:pPr>
+            <a:r>
+              <a:t>Optimizer: AdamW (lr=1e-4, wd=1e-4) + CosineAnnealingLR</a:t>
+            </a:r>
           </a:p>
           <a:p>
             <a:pPr>
               <a:spcAft>
-                <a:spcPts val="800"/>
+                <a:spcPts val="600"/>
               </a:spcAft>
               <a:defRPr sz="1600">
                 <a:solidFill>
@@ -3586,177 +3594,22 @@
               </a:defRPr>
             </a:pPr>
             <a:r>
-              <a:t>Loss: 0.5 * BCEWithLogitsLoss + 0.5 * DiceLoss</a:t>
-            </a:r>
-          </a:p>
-          <a:p>
-            <a:pPr>
-              <a:spcAft>
-                <a:spcPts val="800"/>
-              </a:spcAft>
-              <a:defRPr sz="1600">
-                <a:solidFill>
-                  <a:srgbClr val="333333"/>
-                </a:solidFill>
-              </a:defRPr>
-            </a:pPr>
-            <a:r>
-              <a:t>Optimizer: AdamW (lr=1e-4, weight_decay=1e-4)</a:t>
-            </a:r>
-          </a:p>
-          <a:p>
-            <a:pPr>
-              <a:spcAft>
-                <a:spcPts val="800"/>
-              </a:spcAft>
-              <a:defRPr sz="1600">
-                <a:solidFill>
-                  <a:srgbClr val="333333"/>
-                </a:solidFill>
-              </a:defRPr>
-            </a:pPr>
-            <a:r>
-              <a:t>Schedule: CosineAnnealingLR (T_max=50)</a:t>
-            </a:r>
-          </a:p>
-          <a:p>
-            <a:pPr>
-              <a:spcAft>
-                <a:spcPts val="800"/>
-              </a:spcAft>
-              <a:defRPr sz="1600">
-                <a:solidFill>
-                  <a:srgbClr val="333333"/>
-                </a:solidFill>
-              </a:defRPr>
-            </a:pPr>
-            <a:r>
-              <a:t>Early stopping: patience=10 epochs</a:t>
-            </a:r>
-          </a:p>
-          <a:p>
-            <a:pPr>
-              <a:spcAft>
-                <a:spcPts val="800"/>
-              </a:spcAft>
-              <a:defRPr sz="1600">
-                <a:solidFill>
-                  <a:srgbClr val="333333"/>
-                </a:solidFill>
-              </a:defRPr>
-            </a:pPr>
-          </a:p>
-          <a:p>
-            <a:pPr>
-              <a:spcAft>
-                <a:spcPts val="800"/>
-              </a:spcAft>
-              <a:defRPr sz="1600">
-                <a:solidFill>
-                  <a:srgbClr val="333333"/>
-                </a:solidFill>
-              </a:defRPr>
-            </a:pPr>
-            <a:r>
-              <a:t>Key Design Decisions:</a:t>
-            </a:r>
-          </a:p>
-          <a:p>
-            <a:pPr lvl="1">
-              <a:spcAft>
-                <a:spcPts val="800"/>
-              </a:spcAft>
-              <a:defRPr sz="1400">
-                <a:solidFill>
-                  <a:srgbClr val="606060"/>
-                </a:solidFill>
-              </a:defRPr>
-            </a:pPr>
-            <a:r>
-              <a:t>  BCE + Dice: pixel accuracy + overlap optimization</a:t>
-            </a:r>
-          </a:p>
-          <a:p>
-            <a:pPr lvl="1">
-              <a:spcAft>
-                <a:spcPts val="800"/>
-              </a:spcAft>
-              <a:defRPr sz="1400">
-                <a:solidFill>
-                  <a:srgbClr val="606060"/>
-                </a:solidFill>
-              </a:defRPr>
-            </a:pPr>
-            <a:r>
-              <a:t>  ResNet34: balances capacity with GPU memory (batch=8 on 6GB)</a:t>
-            </a:r>
-          </a:p>
-        </p:txBody>
-      </p:sp>
-    </p:spTree>
-  </p:cSld>
-  <p:clrMapOvr>
-    <a:masterClrMapping/>
-  </p:clrMapOvr>
-</p:sld>
-</file>
-
-<file path=ppt/slides/slide4.xml><?xml version="1.0" encoding="utf-8"?>
-<p:sld xmlns:a="http://schemas.openxmlformats.org/drawingml/2006/main" xmlns:p="http://schemas.openxmlformats.org/presentationml/2006/main" xmlns:r="http://schemas.openxmlformats.org/officeDocument/2006/relationships">
-  <p:cSld>
-    <p:spTree>
-      <p:nvGrpSpPr>
-        <p:cNvPr id="1" name=""/>
-        <p:cNvGrpSpPr/>
-        <p:nvPr/>
-      </p:nvGrpSpPr>
-      <p:grpSpPr/>
-      <p:sp>
-        <p:nvSpPr>
-          <p:cNvPr id="2" name="TextBox 1"/>
-          <p:cNvSpPr txBox="1"/>
-          <p:nvPr/>
-        </p:nvSpPr>
-        <p:spPr>
-          <a:xfrm>
-            <a:off x="548640" y="274320"/>
-            <a:ext cx="10972800" cy="731520"/>
-          </a:xfrm>
-          <a:prstGeom prst="rect">
-            <a:avLst/>
-          </a:prstGeom>
-          <a:noFill/>
-        </p:spPr>
-        <p:txBody>
-          <a:bodyPr wrap="none">
-            <a:spAutoFit/>
-          </a:bodyPr>
-          <a:lstStyle/>
-          <a:p>
-            <a:pPr>
-              <a:defRPr sz="2800" b="1">
-                <a:solidFill>
-                  <a:srgbClr val="1B2A4A"/>
-                </a:solidFill>
-              </a:defRPr>
-            </a:pPr>
-            <a:r>
-              <a:t>Performance Results</a:t>
+              <a:t>Early stopping: patience=10 epochs on val IOU</a:t>
             </a:r>
           </a:p>
         </p:txBody>
       </p:sp>
       <p:graphicFrame>
         <p:nvGraphicFramePr>
-          <p:cNvPr id="3" name="Table 2"/>
+          <p:cNvPr id="4" name="Table 3"/>
           <p:cNvGraphicFramePr>
             <a:graphicFrameLocks noGrp="1"/>
           </p:cNvGraphicFramePr>
           <p:nvPr/>
         </p:nvGraphicFramePr>
         <p:xfrm>
-          <a:off x="731520" y="1371600"/>
-          <a:ext cx="10515600" cy="2011680"/>
+          <a:off x="731520" y="3840480"/>
+          <a:ext cx="4572000" cy="1645920"/>
         </p:xfrm>
         <a:graphic>
           <a:graphicData uri="http://schemas.openxmlformats.org/drawingml/2006/table">
@@ -3765,15 +3618,10 @@
                 <a:tableStyleId>{5C22544A-7EE6-4342-B048-85BDC9FD1C3A}</a:tableStyleId>
               </a:tblPr>
               <a:tblGrid>
-                <a:gridCol w="1502228"/>
-                <a:gridCol w="1502228"/>
-                <a:gridCol w="1502228"/>
-                <a:gridCol w="1502228"/>
-                <a:gridCol w="1502228"/>
-                <a:gridCol w="1502228"/>
-                <a:gridCol w="1502232"/>
+                <a:gridCol w="2286000"/>
+                <a:gridCol w="2286000"/>
               </a:tblGrid>
-              <a:tr h="502920">
+              <a:tr h="411480">
                 <a:tc>
                   <a:txBody>
                     <a:bodyPr/>
@@ -3787,7 +3635,7 @@
                         </a:defRPr>
                       </a:pPr>
                       <a:r>
-                        <a:t>Split</a:t>
+                        <a:t>Hyperparameter</a:t>
                       </a:r>
                     </a:p>
                   </a:txBody>
@@ -3797,6 +3645,714 @@
                     </a:solidFill>
                   </a:tcPr>
                 </a:tc>
+                <a:tc>
+                  <a:txBody>
+                    <a:bodyPr/>
+                    <a:lstStyle/>
+                    <a:p>
+                      <a:pPr>
+                        <a:defRPr sz="1300" b="1">
+                          <a:solidFill>
+                            <a:srgbClr val="FFFFFF"/>
+                          </a:solidFill>
+                        </a:defRPr>
+                      </a:pPr>
+                      <a:r>
+                        <a:t>Best Value</a:t>
+                      </a:r>
+                    </a:p>
+                  </a:txBody>
+                  <a:tcPr>
+                    <a:solidFill>
+                      <a:srgbClr val="1B2A4A"/>
+                    </a:solidFill>
+                  </a:tcPr>
+                </a:tc>
+              </a:tr>
+              <a:tr h="411480">
+                <a:tc>
+                  <a:txBody>
+                    <a:bodyPr/>
+                    <a:lstStyle/>
+                    <a:p>
+                      <a:pPr>
+                        <a:defRPr sz="1300">
+                          <a:solidFill>
+                            <a:srgbClr val="333333"/>
+                          </a:solidFill>
+                        </a:defRPr>
+                      </a:pPr>
+                      <a:r>
+                        <a:t>Learning rate</a:t>
+                      </a:r>
+                    </a:p>
+                  </a:txBody>
+                  <a:tcPr>
+                    <a:solidFill>
+                      <a:srgbClr val="EBF5FB"/>
+                    </a:solidFill>
+                  </a:tcPr>
+                </a:tc>
+                <a:tc>
+                  <a:txBody>
+                    <a:bodyPr/>
+                    <a:lstStyle/>
+                    <a:p>
+                      <a:pPr>
+                        <a:defRPr sz="1300">
+                          <a:solidFill>
+                            <a:srgbClr val="333333"/>
+                          </a:solidFill>
+                        </a:defRPr>
+                      </a:pPr>
+                      <a:r>
+                        <a:t>1e-4</a:t>
+                      </a:r>
+                    </a:p>
+                  </a:txBody>
+                  <a:tcPr>
+                    <a:solidFill>
+                      <a:srgbClr val="EBF5FB"/>
+                    </a:solidFill>
+                  </a:tcPr>
+                </a:tc>
+              </a:tr>
+              <a:tr h="411480">
+                <a:tc>
+                  <a:txBody>
+                    <a:bodyPr/>
+                    <a:lstStyle/>
+                    <a:p>
+                      <a:pPr>
+                        <a:defRPr sz="1300">
+                          <a:solidFill>
+                            <a:srgbClr val="333333"/>
+                          </a:solidFill>
+                        </a:defRPr>
+                      </a:pPr>
+                      <a:r>
+                        <a:t>Batch size</a:t>
+                      </a:r>
+                    </a:p>
+                  </a:txBody>
+                  <a:tcPr/>
+                </a:tc>
+                <a:tc>
+                  <a:txBody>
+                    <a:bodyPr/>
+                    <a:lstStyle/>
+                    <a:p>
+                      <a:pPr>
+                        <a:defRPr sz="1300">
+                          <a:solidFill>
+                            <a:srgbClr val="333333"/>
+                          </a:solidFill>
+                        </a:defRPr>
+                      </a:pPr>
+                      <a:r>
+                        <a:t>8</a:t>
+                      </a:r>
+                    </a:p>
+                  </a:txBody>
+                  <a:tcPr/>
+                </a:tc>
+              </a:tr>
+              <a:tr h="411480">
+                <a:tc>
+                  <a:txBody>
+                    <a:bodyPr/>
+                    <a:lstStyle/>
+                    <a:p>
+                      <a:pPr>
+                        <a:defRPr sz="1300">
+                          <a:solidFill>
+                            <a:srgbClr val="333333"/>
+                          </a:solidFill>
+                        </a:defRPr>
+                      </a:pPr>
+                      <a:r>
+                        <a:t>Epochs</a:t>
+                      </a:r>
+                    </a:p>
+                  </a:txBody>
+                  <a:tcPr>
+                    <a:solidFill>
+                      <a:srgbClr val="EBF5FB"/>
+                    </a:solidFill>
+                  </a:tcPr>
+                </a:tc>
+                <a:tc>
+                  <a:txBody>
+                    <a:bodyPr/>
+                    <a:lstStyle/>
+                    <a:p>
+                      <a:pPr>
+                        <a:defRPr sz="1300">
+                          <a:solidFill>
+                            <a:srgbClr val="333333"/>
+                          </a:solidFill>
+                        </a:defRPr>
+                      </a:pPr>
+                      <a:r>
+                        <a:t>50 (stopped at 34)</a:t>
+                      </a:r>
+                    </a:p>
+                  </a:txBody>
+                  <a:tcPr>
+                    <a:solidFill>
+                      <a:srgbClr val="EBF5FB"/>
+                    </a:solidFill>
+                  </a:tcPr>
+                </a:tc>
+              </a:tr>
+            </a:tbl>
+          </a:graphicData>
+        </a:graphic>
+      </p:graphicFrame>
+    </p:spTree>
+  </p:cSld>
+  <p:clrMapOvr>
+    <a:masterClrMapping/>
+  </p:clrMapOvr>
+</p:sld>
+</file>
+
+<file path=ppt/slides/slide4.xml><?xml version="1.0" encoding="utf-8"?>
+<p:sld xmlns:a="http://schemas.openxmlformats.org/drawingml/2006/main" xmlns:p="http://schemas.openxmlformats.org/presentationml/2006/main" xmlns:r="http://schemas.openxmlformats.org/officeDocument/2006/relationships">
+  <p:cSld>
+    <p:bg>
+      <p:bgPr>
+        <a:solidFill>
+          <a:srgbClr val="F5F7FA"/>
+        </a:solidFill>
+        <a:effectLst/>
+      </p:bgPr>
+    </p:bg>
+    <p:spTree>
+      <p:nvGrpSpPr>
+        <p:cNvPr id="1" name=""/>
+        <p:cNvGrpSpPr/>
+        <p:nvPr/>
+      </p:nvGrpSpPr>
+      <p:grpSpPr/>
+      <p:sp>
+        <p:nvSpPr>
+          <p:cNvPr id="2" name="TextBox 1"/>
+          <p:cNvSpPr txBox="1"/>
+          <p:nvPr/>
+        </p:nvSpPr>
+        <p:spPr>
+          <a:xfrm>
+            <a:off x="548640" y="274320"/>
+            <a:ext cx="10972800" cy="731520"/>
+          </a:xfrm>
+          <a:prstGeom prst="rect">
+            <a:avLst/>
+          </a:prstGeom>
+          <a:noFill/>
+        </p:spPr>
+        <p:txBody>
+          <a:bodyPr wrap="square">
+            <a:spAutoFit/>
+          </a:bodyPr>
+          <a:lstStyle/>
+          <a:p>
+            <a:pPr algn="ctr">
+              <a:defRPr sz="2800" b="1">
+                <a:solidFill>
+                  <a:srgbClr val="333333"/>
+                </a:solidFill>
+              </a:defRPr>
+            </a:pPr>
+            <a:r>
+              <a:t>Performance</a:t>
+            </a:r>
+          </a:p>
+        </p:txBody>
+      </p:sp>
+      <p:sp>
+        <p:nvSpPr>
+          <p:cNvPr id="3" name="TextBox 2"/>
+          <p:cNvSpPr txBox="1"/>
+          <p:nvPr/>
+        </p:nvSpPr>
+        <p:spPr>
+          <a:xfrm>
+            <a:off x="731520" y="1097280"/>
+            <a:ext cx="5029200" cy="731520"/>
+          </a:xfrm>
+          <a:prstGeom prst="rect">
+            <a:avLst/>
+          </a:prstGeom>
+          <a:noFill/>
+        </p:spPr>
+        <p:txBody>
+          <a:bodyPr wrap="square">
+            <a:spAutoFit/>
+          </a:bodyPr>
+          <a:lstStyle/>
+          <a:p>
+            <a:pPr algn="ctr">
+              <a:defRPr sz="1800" b="1">
+                <a:solidFill>
+                  <a:srgbClr val="333333"/>
+                </a:solidFill>
+              </a:defRPr>
+            </a:pPr>
+            <a:r>
+              <a:t>Grid Search (top 3 of 6)</a:t>
+            </a:r>
+          </a:p>
+        </p:txBody>
+      </p:sp>
+      <p:graphicFrame>
+        <p:nvGraphicFramePr>
+          <p:cNvPr id="4" name="Table 3"/>
+          <p:cNvGraphicFramePr>
+            <a:graphicFrameLocks noGrp="1"/>
+          </p:cNvGraphicFramePr>
+          <p:nvPr/>
+        </p:nvGraphicFramePr>
+        <p:xfrm>
+          <a:off x="731520" y="1737360"/>
+          <a:ext cx="5029200" cy="1828800"/>
+        </p:xfrm>
+        <a:graphic>
+          <a:graphicData uri="http://schemas.openxmlformats.org/drawingml/2006/table">
+            <a:tbl>
+              <a:tblPr firstRow="1" bandRow="1">
+                <a:tableStyleId>{5C22544A-7EE6-4342-B048-85BDC9FD1C3A}</a:tableStyleId>
+              </a:tblPr>
+              <a:tblGrid>
+                <a:gridCol w="1257300"/>
+                <a:gridCol w="1257300"/>
+                <a:gridCol w="1257300"/>
+                <a:gridCol w="1257300"/>
+              </a:tblGrid>
+              <a:tr h="457200">
+                <a:tc>
+                  <a:txBody>
+                    <a:bodyPr/>
+                    <a:lstStyle/>
+                    <a:p>
+                      <a:pPr>
+                        <a:defRPr sz="1300" b="1">
+                          <a:solidFill>
+                            <a:srgbClr val="FFFFFF"/>
+                          </a:solidFill>
+                        </a:defRPr>
+                      </a:pPr>
+                      <a:r>
+                        <a:t>LR</a:t>
+                      </a:r>
+                    </a:p>
+                  </a:txBody>
+                  <a:tcPr>
+                    <a:solidFill>
+                      <a:srgbClr val="1B2A4A"/>
+                    </a:solidFill>
+                  </a:tcPr>
+                </a:tc>
+                <a:tc>
+                  <a:txBody>
+                    <a:bodyPr/>
+                    <a:lstStyle/>
+                    <a:p>
+                      <a:pPr>
+                        <a:defRPr sz="1300" b="1">
+                          <a:solidFill>
+                            <a:srgbClr val="FFFFFF"/>
+                          </a:solidFill>
+                        </a:defRPr>
+                      </a:pPr>
+                      <a:r>
+                        <a:t>Batch</a:t>
+                      </a:r>
+                    </a:p>
+                  </a:txBody>
+                  <a:tcPr>
+                    <a:solidFill>
+                      <a:srgbClr val="1B2A4A"/>
+                    </a:solidFill>
+                  </a:tcPr>
+                </a:tc>
+                <a:tc>
+                  <a:txBody>
+                    <a:bodyPr/>
+                    <a:lstStyle/>
+                    <a:p>
+                      <a:pPr>
+                        <a:defRPr sz="1300" b="1">
+                          <a:solidFill>
+                            <a:srgbClr val="FFFFFF"/>
+                          </a:solidFill>
+                        </a:defRPr>
+                      </a:pPr>
+                      <a:r>
+                        <a:t>IOU</a:t>
+                      </a:r>
+                    </a:p>
+                  </a:txBody>
+                  <a:tcPr>
+                    <a:solidFill>
+                      <a:srgbClr val="1B2A4A"/>
+                    </a:solidFill>
+                  </a:tcPr>
+                </a:tc>
+                <a:tc>
+                  <a:txBody>
+                    <a:bodyPr/>
+                    <a:lstStyle/>
+                    <a:p>
+                      <a:pPr>
+                        <a:defRPr sz="1300" b="1">
+                          <a:solidFill>
+                            <a:srgbClr val="FFFFFF"/>
+                          </a:solidFill>
+                        </a:defRPr>
+                      </a:pPr>
+                      <a:r>
+                        <a:t>Accuracy</a:t>
+                      </a:r>
+                    </a:p>
+                  </a:txBody>
+                  <a:tcPr>
+                    <a:solidFill>
+                      <a:srgbClr val="1B2A4A"/>
+                    </a:solidFill>
+                  </a:tcPr>
+                </a:tc>
+              </a:tr>
+              <a:tr h="457200">
+                <a:tc>
+                  <a:txBody>
+                    <a:bodyPr/>
+                    <a:lstStyle/>
+                    <a:p>
+                      <a:pPr>
+                        <a:defRPr sz="1300">
+                          <a:solidFill>
+                            <a:srgbClr val="333333"/>
+                          </a:solidFill>
+                        </a:defRPr>
+                      </a:pPr>
+                      <a:r>
+                        <a:t>1e-4</a:t>
+                      </a:r>
+                    </a:p>
+                  </a:txBody>
+                  <a:tcPr>
+                    <a:solidFill>
+                      <a:srgbClr val="EBF5FB"/>
+                    </a:solidFill>
+                  </a:tcPr>
+                </a:tc>
+                <a:tc>
+                  <a:txBody>
+                    <a:bodyPr/>
+                    <a:lstStyle/>
+                    <a:p>
+                      <a:pPr>
+                        <a:defRPr sz="1300">
+                          <a:solidFill>
+                            <a:srgbClr val="333333"/>
+                          </a:solidFill>
+                        </a:defRPr>
+                      </a:pPr>
+                      <a:r>
+                        <a:t>8</a:t>
+                      </a:r>
+                    </a:p>
+                  </a:txBody>
+                  <a:tcPr>
+                    <a:solidFill>
+                      <a:srgbClr val="EBF5FB"/>
+                    </a:solidFill>
+                  </a:tcPr>
+                </a:tc>
+                <a:tc>
+                  <a:txBody>
+                    <a:bodyPr/>
+                    <a:lstStyle/>
+                    <a:p>
+                      <a:pPr>
+                        <a:defRPr sz="1300">
+                          <a:solidFill>
+                            <a:srgbClr val="333333"/>
+                          </a:solidFill>
+                        </a:defRPr>
+                      </a:pPr>
+                      <a:r>
+                        <a:t>0.8018</a:t>
+                      </a:r>
+                    </a:p>
+                  </a:txBody>
+                  <a:tcPr>
+                    <a:solidFill>
+                      <a:srgbClr val="EBF5FB"/>
+                    </a:solidFill>
+                  </a:tcPr>
+                </a:tc>
+                <a:tc>
+                  <a:txBody>
+                    <a:bodyPr/>
+                    <a:lstStyle/>
+                    <a:p>
+                      <a:pPr>
+                        <a:defRPr sz="1300">
+                          <a:solidFill>
+                            <a:srgbClr val="333333"/>
+                          </a:solidFill>
+                        </a:defRPr>
+                      </a:pPr>
+                      <a:r>
+                        <a:t>92.65%</a:t>
+                      </a:r>
+                    </a:p>
+                  </a:txBody>
+                  <a:tcPr>
+                    <a:solidFill>
+                      <a:srgbClr val="EBF5FB"/>
+                    </a:solidFill>
+                  </a:tcPr>
+                </a:tc>
+              </a:tr>
+              <a:tr h="457200">
+                <a:tc>
+                  <a:txBody>
+                    <a:bodyPr/>
+                    <a:lstStyle/>
+                    <a:p>
+                      <a:pPr>
+                        <a:defRPr sz="1300">
+                          <a:solidFill>
+                            <a:srgbClr val="333333"/>
+                          </a:solidFill>
+                        </a:defRPr>
+                      </a:pPr>
+                      <a:r>
+                        <a:t>5e-5</a:t>
+                      </a:r>
+                    </a:p>
+                  </a:txBody>
+                  <a:tcPr/>
+                </a:tc>
+                <a:tc>
+                  <a:txBody>
+                    <a:bodyPr/>
+                    <a:lstStyle/>
+                    <a:p>
+                      <a:pPr>
+                        <a:defRPr sz="1300">
+                          <a:solidFill>
+                            <a:srgbClr val="333333"/>
+                          </a:solidFill>
+                        </a:defRPr>
+                      </a:pPr>
+                      <a:r>
+                        <a:t>8</a:t>
+                      </a:r>
+                    </a:p>
+                  </a:txBody>
+                  <a:tcPr/>
+                </a:tc>
+                <a:tc>
+                  <a:txBody>
+                    <a:bodyPr/>
+                    <a:lstStyle/>
+                    <a:p>
+                      <a:pPr>
+                        <a:defRPr sz="1300">
+                          <a:solidFill>
+                            <a:srgbClr val="333333"/>
+                          </a:solidFill>
+                        </a:defRPr>
+                      </a:pPr>
+                      <a:r>
+                        <a:t>0.7928</a:t>
+                      </a:r>
+                    </a:p>
+                  </a:txBody>
+                  <a:tcPr/>
+                </a:tc>
+                <a:tc>
+                  <a:txBody>
+                    <a:bodyPr/>
+                    <a:lstStyle/>
+                    <a:p>
+                      <a:pPr>
+                        <a:defRPr sz="1300">
+                          <a:solidFill>
+                            <a:srgbClr val="333333"/>
+                          </a:solidFill>
+                        </a:defRPr>
+                      </a:pPr>
+                      <a:r>
+                        <a:t>92.31%</a:t>
+                      </a:r>
+                    </a:p>
+                  </a:txBody>
+                  <a:tcPr/>
+                </a:tc>
+              </a:tr>
+              <a:tr h="457200">
+                <a:tc>
+                  <a:txBody>
+                    <a:bodyPr/>
+                    <a:lstStyle/>
+                    <a:p>
+                      <a:pPr>
+                        <a:defRPr sz="1300">
+                          <a:solidFill>
+                            <a:srgbClr val="333333"/>
+                          </a:solidFill>
+                        </a:defRPr>
+                      </a:pPr>
+                      <a:r>
+                        <a:t>1e-4</a:t>
+                      </a:r>
+                    </a:p>
+                  </a:txBody>
+                  <a:tcPr>
+                    <a:solidFill>
+                      <a:srgbClr val="EBF5FB"/>
+                    </a:solidFill>
+                  </a:tcPr>
+                </a:tc>
+                <a:tc>
+                  <a:txBody>
+                    <a:bodyPr/>
+                    <a:lstStyle/>
+                    <a:p>
+                      <a:pPr>
+                        <a:defRPr sz="1300">
+                          <a:solidFill>
+                            <a:srgbClr val="333333"/>
+                          </a:solidFill>
+                        </a:defRPr>
+                      </a:pPr>
+                      <a:r>
+                        <a:t>16</a:t>
+                      </a:r>
+                    </a:p>
+                  </a:txBody>
+                  <a:tcPr>
+                    <a:solidFill>
+                      <a:srgbClr val="EBF5FB"/>
+                    </a:solidFill>
+                  </a:tcPr>
+                </a:tc>
+                <a:tc>
+                  <a:txBody>
+                    <a:bodyPr/>
+                    <a:lstStyle/>
+                    <a:p>
+                      <a:pPr>
+                        <a:defRPr sz="1300">
+                          <a:solidFill>
+                            <a:srgbClr val="333333"/>
+                          </a:solidFill>
+                        </a:defRPr>
+                      </a:pPr>
+                      <a:r>
+                        <a:t>0.7542</a:t>
+                      </a:r>
+                    </a:p>
+                  </a:txBody>
+                  <a:tcPr>
+                    <a:solidFill>
+                      <a:srgbClr val="EBF5FB"/>
+                    </a:solidFill>
+                  </a:tcPr>
+                </a:tc>
+                <a:tc>
+                  <a:txBody>
+                    <a:bodyPr/>
+                    <a:lstStyle/>
+                    <a:p>
+                      <a:pPr>
+                        <a:defRPr sz="1300">
+                          <a:solidFill>
+                            <a:srgbClr val="333333"/>
+                          </a:solidFill>
+                        </a:defRPr>
+                      </a:pPr>
+                      <a:r>
+                        <a:t>90.86%</a:t>
+                      </a:r>
+                    </a:p>
+                  </a:txBody>
+                  <a:tcPr>
+                    <a:solidFill>
+                      <a:srgbClr val="EBF5FB"/>
+                    </a:solidFill>
+                  </a:tcPr>
+                </a:tc>
+              </a:tr>
+            </a:tbl>
+          </a:graphicData>
+        </a:graphic>
+      </p:graphicFrame>
+      <p:sp>
+        <p:nvSpPr>
+          <p:cNvPr id="5" name="TextBox 4"/>
+          <p:cNvSpPr txBox="1"/>
+          <p:nvPr/>
+        </p:nvSpPr>
+        <p:spPr>
+          <a:xfrm>
+            <a:off x="6400800" y="1097280"/>
+            <a:ext cx="5029200" cy="731520"/>
+          </a:xfrm>
+          <a:prstGeom prst="rect">
+            <a:avLst/>
+          </a:prstGeom>
+          <a:noFill/>
+        </p:spPr>
+        <p:txBody>
+          <a:bodyPr wrap="square">
+            <a:spAutoFit/>
+          </a:bodyPr>
+          <a:lstStyle/>
+          <a:p>
+            <a:pPr algn="ctr">
+              <a:defRPr sz="1800" b="1">
+                <a:solidFill>
+                  <a:srgbClr val="333333"/>
+                </a:solidFill>
+              </a:defRPr>
+            </a:pPr>
+            <a:r>
+              <a:t>Final Model (Test Set)</a:t>
+            </a:r>
+          </a:p>
+        </p:txBody>
+      </p:sp>
+      <p:graphicFrame>
+        <p:nvGraphicFramePr>
+          <p:cNvPr id="6" name="Table 5"/>
+          <p:cNvGraphicFramePr>
+            <a:graphicFrameLocks noGrp="1"/>
+          </p:cNvGraphicFramePr>
+          <p:nvPr/>
+        </p:nvGraphicFramePr>
+        <p:xfrm>
+          <a:off x="6400800" y="1737360"/>
+          <a:ext cx="5029200" cy="1097280"/>
+        </p:xfrm>
+        <a:graphic>
+          <a:graphicData uri="http://schemas.openxmlformats.org/drawingml/2006/table">
+            <a:tbl>
+              <a:tblPr firstRow="1" bandRow="1">
+                <a:tableStyleId>{5C22544A-7EE6-4342-B048-85BDC9FD1C3A}</a:tableStyleId>
+              </a:tblPr>
+              <a:tblGrid>
+                <a:gridCol w="1257300"/>
+                <a:gridCol w="1257300"/>
+                <a:gridCol w="1257300"/>
+                <a:gridCol w="1257300"/>
+              </a:tblGrid>
+              <a:tr h="548640">
                 <a:tc>
                   <a:txBody>
                     <a:bodyPr/>
@@ -3889,54 +4445,8 @@
                     </a:solidFill>
                   </a:tcPr>
                 </a:tc>
-                <a:tc>
-                  <a:txBody>
-                    <a:bodyPr/>
-                    <a:lstStyle/>
-                    <a:p>
-                      <a:pPr>
-                        <a:defRPr sz="1300" b="1">
-                          <a:solidFill>
-                            <a:srgbClr val="FFFFFF"/>
-                          </a:solidFill>
-                        </a:defRPr>
-                      </a:pPr>
-                      <a:r>
-                        <a:t>Loss</a:t>
-                      </a:r>
-                    </a:p>
-                  </a:txBody>
-                  <a:tcPr>
-                    <a:solidFill>
-                      <a:srgbClr val="1B2A4A"/>
-                    </a:solidFill>
-                  </a:tcPr>
-                </a:tc>
-                <a:tc>
-                  <a:txBody>
-                    <a:bodyPr/>
-                    <a:lstStyle/>
-                    <a:p>
-                      <a:pPr>
-                        <a:defRPr sz="1300" b="1">
-                          <a:solidFill>
-                            <a:srgbClr val="FFFFFF"/>
-                          </a:solidFill>
-                        </a:defRPr>
-                      </a:pPr>
-                      <a:r>
-                        <a:t>Best Epoch</a:t>
-                      </a:r>
-                    </a:p>
-                  </a:txBody>
-                  <a:tcPr>
-                    <a:solidFill>
-                      <a:srgbClr val="1B2A4A"/>
-                    </a:solidFill>
-                  </a:tcPr>
-                </a:tc>
               </a:tr>
-              <a:tr h="502920">
+              <a:tr h="548640">
                 <a:tc>
                   <a:txBody>
                     <a:bodyPr/>
@@ -3950,7 +4460,7 @@
                         </a:defRPr>
                       </a:pPr>
                       <a:r>
-                        <a:t>Validation</a:t>
+                        <a:t>0.8249</a:t>
                       </a:r>
                     </a:p>
                   </a:txBody>
@@ -3973,7 +4483,7 @@
                         </a:defRPr>
                       </a:pPr>
                       <a:r>
-                        <a:t>0.7865</a:t>
+                        <a:t>93.80%</a:t>
                       </a:r>
                     </a:p>
                   </a:txBody>
@@ -3996,7 +4506,7 @@
                         </a:defRPr>
                       </a:pPr>
                       <a:r>
-                        <a:t>0.9213</a:t>
+                        <a:t>91.90%</a:t>
                       </a:r>
                     </a:p>
                   </a:txBody>
@@ -4019,76 +4529,7 @@
                         </a:defRPr>
                       </a:pPr>
                       <a:r>
-                        <a:t>0.9028</a:t>
-                      </a:r>
-                    </a:p>
-                  </a:txBody>
-                  <a:tcPr>
-                    <a:solidFill>
-                      <a:srgbClr val="EBF5FB"/>
-                    </a:solidFill>
-                  </a:tcPr>
-                </a:tc>
-                <a:tc>
-                  <a:txBody>
-                    <a:bodyPr/>
-                    <a:lstStyle/>
-                    <a:p>
-                      <a:pPr>
-                        <a:defRPr sz="1300">
-                          <a:solidFill>
-                            <a:srgbClr val="333333"/>
-                          </a:solidFill>
-                        </a:defRPr>
-                      </a:pPr>
-                      <a:r>
-                        <a:t>0.8621</a:t>
-                      </a:r>
-                    </a:p>
-                  </a:txBody>
-                  <a:tcPr>
-                    <a:solidFill>
-                      <a:srgbClr val="EBF5FB"/>
-                    </a:solidFill>
-                  </a:tcPr>
-                </a:tc>
-                <a:tc>
-                  <a:txBody>
-                    <a:bodyPr/>
-                    <a:lstStyle/>
-                    <a:p>
-                      <a:pPr>
-                        <a:defRPr sz="1300">
-                          <a:solidFill>
-                            <a:srgbClr val="333333"/>
-                          </a:solidFill>
-                        </a:defRPr>
-                      </a:pPr>
-                      <a:r>
-                        <a:t>0.1812</a:t>
-                      </a:r>
-                    </a:p>
-                  </a:txBody>
-                  <a:tcPr>
-                    <a:solidFill>
-                      <a:srgbClr val="EBF5FB"/>
-                    </a:solidFill>
-                  </a:tcPr>
-                </a:tc>
-                <a:tc>
-                  <a:txBody>
-                    <a:bodyPr/>
-                    <a:lstStyle/>
-                    <a:p>
-                      <a:pPr>
-                        <a:defRPr sz="1300">
-                          <a:solidFill>
-                            <a:srgbClr val="333333"/>
-                          </a:solidFill>
-                        </a:defRPr>
-                      </a:pPr>
-                      <a:r>
-                        <a:t>34</a:t>
+                        <a:t>88.70%</a:t>
                       </a:r>
                     </a:p>
                   </a:txBody>
@@ -4099,289 +4540,19 @@
                   </a:tcPr>
                 </a:tc>
               </a:tr>
-              <a:tr h="502920">
-                <a:tc>
-                  <a:txBody>
-                    <a:bodyPr/>
-                    <a:lstStyle/>
-                    <a:p>
-                      <a:pPr>
-                        <a:defRPr sz="1300">
-                          <a:solidFill>
-                            <a:srgbClr val="333333"/>
-                          </a:solidFill>
-                        </a:defRPr>
-                      </a:pPr>
-                      <a:r>
-                        <a:t>Test</a:t>
-                      </a:r>
-                    </a:p>
-                  </a:txBody>
-                  <a:tcPr/>
-                </a:tc>
-                <a:tc>
-                  <a:txBody>
-                    <a:bodyPr/>
-                    <a:lstStyle/>
-                    <a:p>
-                      <a:pPr>
-                        <a:defRPr sz="1300">
-                          <a:solidFill>
-                            <a:srgbClr val="333333"/>
-                          </a:solidFill>
-                        </a:defRPr>
-                      </a:pPr>
-                      <a:r>
-                        <a:t>0.8249</a:t>
-                      </a:r>
-                    </a:p>
-                  </a:txBody>
-                  <a:tcPr/>
-                </a:tc>
-                <a:tc>
-                  <a:txBody>
-                    <a:bodyPr/>
-                    <a:lstStyle/>
-                    <a:p>
-                      <a:pPr>
-                        <a:defRPr sz="1300">
-                          <a:solidFill>
-                            <a:srgbClr val="333333"/>
-                          </a:solidFill>
-                        </a:defRPr>
-                      </a:pPr>
-                      <a:r>
-                        <a:t>0.9380</a:t>
-                      </a:r>
-                    </a:p>
-                  </a:txBody>
-                  <a:tcPr/>
-                </a:tc>
-                <a:tc>
-                  <a:txBody>
-                    <a:bodyPr/>
-                    <a:lstStyle/>
-                    <a:p>
-                      <a:pPr>
-                        <a:defRPr sz="1300">
-                          <a:solidFill>
-                            <a:srgbClr val="333333"/>
-                          </a:solidFill>
-                        </a:defRPr>
-                      </a:pPr>
-                      <a:r>
-                        <a:t>0.9190</a:t>
-                      </a:r>
-                    </a:p>
-                  </a:txBody>
-                  <a:tcPr/>
-                </a:tc>
-                <a:tc>
-                  <a:txBody>
-                    <a:bodyPr/>
-                    <a:lstStyle/>
-                    <a:p>
-                      <a:pPr>
-                        <a:defRPr sz="1300">
-                          <a:solidFill>
-                            <a:srgbClr val="333333"/>
-                          </a:solidFill>
-                        </a:defRPr>
-                      </a:pPr>
-                      <a:r>
-                        <a:t>0.8870</a:t>
-                      </a:r>
-                    </a:p>
-                  </a:txBody>
-                  <a:tcPr/>
-                </a:tc>
-                <a:tc>
-                  <a:txBody>
-                    <a:bodyPr/>
-                    <a:lstStyle/>
-                    <a:p>
-                      <a:pPr>
-                        <a:defRPr sz="1300">
-                          <a:solidFill>
-                            <a:srgbClr val="333333"/>
-                          </a:solidFill>
-                        </a:defRPr>
-                      </a:pPr>
-                      <a:r>
-                        <a:t>0.1547</a:t>
-                      </a:r>
-                    </a:p>
-                  </a:txBody>
-                  <a:tcPr/>
-                </a:tc>
-                <a:tc>
-                  <a:txBody>
-                    <a:bodyPr/>
-                    <a:lstStyle/>
-                    <a:p>
-                      <a:pPr>
-                        <a:defRPr sz="1300">
-                          <a:solidFill>
-                            <a:srgbClr val="333333"/>
-                          </a:solidFill>
-                        </a:defRPr>
-                      </a:pPr>
-                      <a:r>
-                        <a:t>34</a:t>
-                      </a:r>
-                    </a:p>
-                  </a:txBody>
-                  <a:tcPr/>
-                </a:tc>
-              </a:tr>
-              <a:tr h="502920">
-                <a:tc>
-                  <a:txBody>
-                    <a:bodyPr/>
-                    <a:lstStyle/>
-                    <a:p>
-                      <a:pPr>
-                        <a:defRPr sz="1300">
-                          <a:solidFill>
-                            <a:srgbClr val="333333"/>
-                          </a:solidFill>
-                        </a:defRPr>
-                      </a:pPr>
-                      <a:r>
-                        <a:t>Grid Search Best</a:t>
-                      </a:r>
-                    </a:p>
-                  </a:txBody>
-                  <a:tcPr/>
-                </a:tc>
-                <a:tc>
-                  <a:txBody>
-                    <a:bodyPr/>
-                    <a:lstStyle/>
-                    <a:p>
-                      <a:pPr>
-                        <a:defRPr sz="1300">
-                          <a:solidFill>
-                            <a:srgbClr val="333333"/>
-                          </a:solidFill>
-                        </a:defRPr>
-                      </a:pPr>
-                      <a:r>
-                        <a:t>0.8018</a:t>
-                      </a:r>
-                    </a:p>
-                  </a:txBody>
-                  <a:tcPr/>
-                </a:tc>
-                <a:tc>
-                  <a:txBody>
-                    <a:bodyPr/>
-                    <a:lstStyle/>
-                    <a:p>
-                      <a:pPr>
-                        <a:defRPr sz="1300">
-                          <a:solidFill>
-                            <a:srgbClr val="333333"/>
-                          </a:solidFill>
-                        </a:defRPr>
-                      </a:pPr>
-                      <a:r>
-                        <a:t>0.9265</a:t>
-                      </a:r>
-                    </a:p>
-                  </a:txBody>
-                  <a:tcPr/>
-                </a:tc>
-                <a:tc>
-                  <a:txBody>
-                    <a:bodyPr/>
-                    <a:lstStyle/>
-                    <a:p>
-                      <a:pPr>
-                        <a:defRPr sz="1300">
-                          <a:solidFill>
-                            <a:srgbClr val="333333"/>
-                          </a:solidFill>
-                        </a:defRPr>
-                      </a:pPr>
-                      <a:r>
-                        <a:t>0.9093</a:t>
-                      </a:r>
-                    </a:p>
-                  </a:txBody>
-                  <a:tcPr/>
-                </a:tc>
-                <a:tc>
-                  <a:txBody>
-                    <a:bodyPr/>
-                    <a:lstStyle/>
-                    <a:p>
-                      <a:pPr>
-                        <a:defRPr sz="1300">
-                          <a:solidFill>
-                            <a:srgbClr val="333333"/>
-                          </a:solidFill>
-                        </a:defRPr>
-                      </a:pPr>
-                      <a:r>
-                        <a:t>0.8696</a:t>
-                      </a:r>
-                    </a:p>
-                  </a:txBody>
-                  <a:tcPr/>
-                </a:tc>
-                <a:tc>
-                  <a:txBody>
-                    <a:bodyPr/>
-                    <a:lstStyle/>
-                    <a:p>
-                      <a:pPr>
-                        <a:defRPr sz="1300">
-                          <a:solidFill>
-                            <a:srgbClr val="333333"/>
-                          </a:solidFill>
-                        </a:defRPr>
-                      </a:pPr>
-                      <a:r>
-                        <a:t>0.1710</a:t>
-                      </a:r>
-                    </a:p>
-                  </a:txBody>
-                  <a:tcPr/>
-                </a:tc>
-                <a:tc>
-                  <a:txBody>
-                    <a:bodyPr/>
-                    <a:lstStyle/>
-                    <a:p>
-                      <a:pPr>
-                        <a:defRPr sz="1300">
-                          <a:solidFill>
-                            <a:srgbClr val="333333"/>
-                          </a:solidFill>
-                        </a:defRPr>
-                      </a:pPr>
-                      <a:r>
-                        <a:t>50</a:t>
-                      </a:r>
-                    </a:p>
-                  </a:txBody>
-                  <a:tcPr/>
-                </a:tc>
-              </a:tr>
             </a:tbl>
           </a:graphicData>
         </a:graphic>
       </p:graphicFrame>
       <p:sp>
         <p:nvSpPr>
-          <p:cNvPr id="4" name="TextBox 3"/>
+          <p:cNvPr id="7" name="TextBox 6"/>
           <p:cNvSpPr txBox="1"/>
           <p:nvPr/>
         </p:nvSpPr>
         <p:spPr>
           <a:xfrm>
-            <a:off x="731520" y="3840480"/>
+            <a:off x="731520" y="4023360"/>
             <a:ext cx="10515600" cy="4572000"/>
           </a:xfrm>
           <a:prstGeom prst="rect">
@@ -4397,46 +4568,46 @@
           <a:p>
             <a:pPr>
               <a:spcAft>
-                <a:spcPts val="800"/>
+                <a:spcPts val="600"/>
+              </a:spcAft>
+              <a:defRPr sz="1500">
+                <a:solidFill>
+                  <a:srgbClr val="333333"/>
+                </a:solidFill>
+              </a:defRPr>
+            </a:pPr>
+            <a:r>
+              <a:t>Precision &gt; Recall across all runs -- model under-segments</a:t>
+            </a:r>
+          </a:p>
+          <a:p>
+            <a:pPr lvl="1">
+              <a:spcAft>
+                <a:spcPts val="600"/>
               </a:spcAft>
               <a:defRPr sz="1400">
                 <a:solidFill>
-                  <a:srgbClr val="333333"/>
+                  <a:srgbClr val="808080"/>
                 </a:solidFill>
               </a:defRPr>
             </a:pPr>
             <a:r>
-              <a:t>Precision &gt; Recall in all runs: model under-segments (safer for flood mapping)</a:t>
+              <a:t>  Safer bias for flood mapping: fewer false alarms</a:t>
             </a:r>
           </a:p>
           <a:p>
             <a:pPr>
               <a:spcAft>
-                <a:spcPts val="800"/>
+                <a:spcPts val="600"/>
               </a:spcAft>
-              <a:defRPr sz="1400">
+              <a:defRPr sz="1500">
                 <a:solidFill>
                   <a:srgbClr val="333333"/>
                 </a:solidFill>
               </a:defRPr>
             </a:pPr>
             <a:r>
-              <a:t>Test outperforms validation: no evidence of overfitting</a:t>
-            </a:r>
-          </a:p>
-          <a:p>
-            <a:pPr>
-              <a:spcAft>
-                <a:spcPts val="800"/>
-              </a:spcAft>
-              <a:defRPr sz="1400">
-                <a:solidFill>
-                  <a:srgbClr val="333333"/>
-                </a:solidFill>
-              </a:defRPr>
-            </a:pPr>
-            <a:r>
-              <a:t>Grid search: LR=1e-4, batch=8 best; higher LR diverges, lower LR converges slowly</a:t>
+              <a:t>Test IOU &gt; Val IOU: no overfitting</a:t>
             </a:r>
           </a:p>
         </p:txBody>
@@ -4452,6 +4623,14 @@
 <file path=ppt/slides/slide5.xml><?xml version="1.0" encoding="utf-8"?>
 <p:sld xmlns:a="http://schemas.openxmlformats.org/drawingml/2006/main" xmlns:p="http://schemas.openxmlformats.org/presentationml/2006/main" xmlns:r="http://schemas.openxmlformats.org/officeDocument/2006/relationships">
   <p:cSld>
+    <p:bg>
+      <p:bgPr>
+        <a:solidFill>
+          <a:srgbClr val="F5F7FA"/>
+        </a:solidFill>
+        <a:effectLst/>
+      </p:bgPr>
+    </p:bg>
     <p:spTree>
       <p:nvGrpSpPr>
         <p:cNvPr id="1" name=""/>
@@ -4476,20 +4655,20 @@
           <a:noFill/>
         </p:spPr>
         <p:txBody>
-          <a:bodyPr wrap="none">
+          <a:bodyPr wrap="square">
             <a:spAutoFit/>
           </a:bodyPr>
           <a:lstStyle/>
           <a:p>
-            <a:pPr>
+            <a:pPr algn="ctr">
               <a:defRPr sz="2800" b="1">
                 <a:solidFill>
-                  <a:srgbClr val="1B2A4A"/>
+                  <a:srgbClr val="333333"/>
                 </a:solidFill>
               </a:defRPr>
             </a:pPr>
             <a:r>
-              <a:t>Inference Optimizations</a:t>
+              <a:t>Optimization: 2.2x CPU Speedup with ONNX</a:t>
             </a:r>
           </a:p>
         </p:txBody>
@@ -4578,7 +4757,7 @@
                         </a:defRPr>
                       </a:pPr>
                       <a:r>
-                        <a:t>Latency/tile</a:t>
+                        <a:t>Latency / tile</a:t>
                       </a:r>
                     </a:p>
                   </a:txBody>
@@ -4626,11 +4805,15 @@
                         </a:defRPr>
                       </a:pPr>
                       <a:r>
-                        <a:t>PyTorch</a:t>
+                        <a:t>PyTorch (eager)</a:t>
                       </a:r>
                     </a:p>
                   </a:txBody>
-                  <a:tcPr/>
+                  <a:tcPr>
+                    <a:solidFill>
+                      <a:srgbClr val="EBF5FB"/>
+                    </a:solidFill>
+                  </a:tcPr>
                 </a:tc>
                 <a:tc>
                   <a:txBody>
@@ -4649,7 +4832,11 @@
                       </a:r>
                     </a:p>
                   </a:txBody>
-                  <a:tcPr/>
+                  <a:tcPr>
+                    <a:solidFill>
+                      <a:srgbClr val="EBF5FB"/>
+                    </a:solidFill>
+                  </a:tcPr>
                 </a:tc>
                 <a:tc>
                   <a:txBody>
@@ -4664,11 +4851,15 @@
                         </a:defRPr>
                       </a:pPr>
                       <a:r>
-                        <a:t>~120ms</a:t>
+                        <a:t>~120 ms</a:t>
                       </a:r>
                     </a:p>
                   </a:txBody>
-                  <a:tcPr/>
+                  <a:tcPr>
+                    <a:solidFill>
+                      <a:srgbClr val="EBF5FB"/>
+                    </a:solidFill>
+                  </a:tcPr>
                 </a:tc>
                 <a:tc>
                   <a:txBody>
@@ -4687,7 +4878,11 @@
                       </a:r>
                     </a:p>
                   </a:txBody>
-                  <a:tcPr/>
+                  <a:tcPr>
+                    <a:solidFill>
+                      <a:srgbClr val="EBF5FB"/>
+                    </a:solidFill>
+                  </a:tcPr>
                 </a:tc>
               </a:tr>
               <a:tr h="457200">
@@ -4742,7 +4937,7 @@
                         </a:defRPr>
                       </a:pPr>
                       <a:r>
-                        <a:t>~55ms</a:t>
+                        <a:t>~55 ms</a:t>
                       </a:r>
                     </a:p>
                   </a:txBody>
@@ -4761,7 +4956,7 @@
                         </a:defRPr>
                       </a:pPr>
                       <a:r>
-                        <a:t>~2.2x</a:t>
+                        <a:t>2.2x</a:t>
                       </a:r>
                     </a:p>
                   </a:txBody>
@@ -4786,7 +4981,11 @@
                       </a:r>
                     </a:p>
                   </a:txBody>
-                  <a:tcPr/>
+                  <a:tcPr>
+                    <a:solidFill>
+                      <a:srgbClr val="EBF5FB"/>
+                    </a:solidFill>
+                  </a:tcPr>
                 </a:tc>
                 <a:tc>
                   <a:txBody>
@@ -4805,7 +5004,11 @@
                       </a:r>
                     </a:p>
                   </a:txBody>
-                  <a:tcPr/>
+                  <a:tcPr>
+                    <a:solidFill>
+                      <a:srgbClr val="EBF5FB"/>
+                    </a:solidFill>
+                  </a:tcPr>
                 </a:tc>
                 <a:tc>
                   <a:txBody>
@@ -4820,11 +5023,15 @@
                         </a:defRPr>
                       </a:pPr>
                       <a:r>
-                        <a:t>~15ms</a:t>
+                        <a:t>~15 ms</a:t>
                       </a:r>
                     </a:p>
                   </a:txBody>
-                  <a:tcPr/>
+                  <a:tcPr>
+                    <a:solidFill>
+                      <a:srgbClr val="EBF5FB"/>
+                    </a:solidFill>
+                  </a:tcPr>
                 </a:tc>
                 <a:tc>
                   <a:txBody>
@@ -4839,11 +5046,15 @@
                         </a:defRPr>
                       </a:pPr>
                       <a:r>
-                        <a:t>~8.0x</a:t>
+                        <a:t>8.0x</a:t>
                       </a:r>
                     </a:p>
                   </a:txBody>
-                  <a:tcPr/>
+                  <a:tcPr>
+                    <a:solidFill>
+                      <a:srgbClr val="EBF5FB"/>
+                    </a:solidFill>
+                  </a:tcPr>
                 </a:tc>
               </a:tr>
             </a:tbl>
@@ -4874,7 +5085,7 @@
           <a:p>
             <a:pPr>
               <a:spcAft>
-                <a:spcPts val="800"/>
+                <a:spcPts val="600"/>
               </a:spcAft>
               <a:defRPr sz="1500">
                 <a:solidFill>
@@ -4883,13 +5094,13 @@
               </a:defRPr>
             </a:pPr>
             <a:r>
-              <a:t>Sliding-window tiling: 256x256 tiles, 32px overlap for large rasters (~72 tiles/image)</a:t>
+              <a:t>Sliding-window tiling: 256x256 tiles, 32px overlap (~72 tiles/image)</a:t>
             </a:r>
           </a:p>
           <a:p>
             <a:pPr>
               <a:spcAft>
-                <a:spcPts val="800"/>
+                <a:spcPts val="600"/>
               </a:spcAft>
               <a:defRPr sz="1500">
                 <a:solidFill>
@@ -4898,13 +5109,13 @@
               </a:defRPr>
             </a:pPr>
             <a:r>
-              <a:t>Test-Time Augmentation: horizontal flip averaging (+0.5-1.0% IOU)</a:t>
+              <a:t>Test-Time Augmentation: horizontal flip averaging (+0.5-1% IOU)</a:t>
             </a:r>
           </a:p>
           <a:p>
             <a:pPr>
               <a:spcAft>
-                <a:spcPts val="800"/>
+                <a:spcPts val="600"/>
               </a:spcAft>
               <a:defRPr sz="1500">
                 <a:solidFill>
@@ -4913,13 +5124,13 @@
               </a:defRPr>
             </a:pPr>
             <a:r>
-              <a:t>Dynamic batch axis in ONNX export for flexible input sizing</a:t>
+              <a:t>Auto-fallback: ONNX -&gt; PyTorch -&gt; MLflow registry</a:t>
             </a:r>
           </a:p>
           <a:p>
             <a:pPr>
               <a:spcAft>
-                <a:spcPts val="800"/>
+                <a:spcPts val="600"/>
               </a:spcAft>
               <a:defRPr sz="1500">
                 <a:solidFill>
@@ -4928,7 +5139,7 @@
               </a:defRPr>
             </a:pPr>
             <a:r>
-              <a:t>Multi-backend fallback: ONNX -&gt; PyTorch -&gt; MLflow registry</a:t>
+              <a:t>Dynamic batch axis for flexible input sizing</a:t>
             </a:r>
           </a:p>
         </p:txBody>
@@ -4944,6 +5155,14 @@
 <file path=ppt/slides/slide6.xml><?xml version="1.0" encoding="utf-8"?>
 <p:sld xmlns:a="http://schemas.openxmlformats.org/drawingml/2006/main" xmlns:p="http://schemas.openxmlformats.org/presentationml/2006/main" xmlns:r="http://schemas.openxmlformats.org/officeDocument/2006/relationships">
   <p:cSld>
+    <p:bg>
+      <p:bgPr>
+        <a:solidFill>
+          <a:srgbClr val="F5F7FA"/>
+        </a:solidFill>
+        <a:effectLst/>
+      </p:bgPr>
+    </p:bg>
     <p:spTree>
       <p:nvGrpSpPr>
         <p:cNvPr id="1" name=""/>
@@ -4968,20 +5187,20 @@
           <a:noFill/>
         </p:spPr>
         <p:txBody>
-          <a:bodyPr wrap="none">
+          <a:bodyPr wrap="square">
             <a:spAutoFit/>
           </a:bodyPr>
           <a:lstStyle/>
           <a:p>
-            <a:pPr>
+            <a:pPr algn="ctr">
               <a:defRPr sz="2800" b="1">
                 <a:solidFill>
-                  <a:srgbClr val="1B2A4A"/>
+                  <a:srgbClr val="333333"/>
                 </a:solidFill>
               </a:defRPr>
             </a:pPr>
             <a:r>
-              <a:t>Failure Analysis &amp; Known Limitations</a:t>
+              <a:t>What the Model Misses (Transparency)</a:t>
             </a:r>
           </a:p>
         </p:txBody>
@@ -5098,7 +5317,11 @@
                       </a:r>
                     </a:p>
                   </a:txBody>
-                  <a:tcPr/>
+                  <a:tcPr>
+                    <a:solidFill>
+                      <a:srgbClr val="EBF5FB"/>
+                    </a:solidFill>
+                  </a:tcPr>
                 </a:tc>
                 <a:tc>
                   <a:txBody>
@@ -5117,7 +5340,11 @@
                       </a:r>
                     </a:p>
                   </a:txBody>
-                  <a:tcPr/>
+                  <a:tcPr>
+                    <a:solidFill>
+                      <a:srgbClr val="EBF5FB"/>
+                    </a:solidFill>
+                  </a:tcPr>
                 </a:tc>
                 <a:tc>
                   <a:txBody>
@@ -5136,7 +5363,11 @@
                       </a:r>
                     </a:p>
                   </a:txBody>
-                  <a:tcPr/>
+                  <a:tcPr>
+                    <a:solidFill>
+                      <a:srgbClr val="EBF5FB"/>
+                    </a:solidFill>
+                  </a:tcPr>
                 </a:tc>
               </a:tr>
               <a:tr h="502920">
@@ -5153,7 +5384,7 @@
                         </a:defRPr>
                       </a:pPr>
                       <a:r>
-                        <a:t>Shadow/dark terrain</a:t>
+                        <a:t>Shadow / dark terrain</a:t>
                       </a:r>
                     </a:p>
                   </a:txBody>
@@ -5191,7 +5422,7 @@
                         </a:defRPr>
                       </a:pPr>
                       <a:r>
-                        <a:t>RGB-only input; NIR band needed</a:t>
+                        <a:t>RGB-only input; NIR disambiguates</a:t>
                       </a:r>
                     </a:p>
                   </a:txBody>
@@ -5216,7 +5447,11 @@
                       </a:r>
                     </a:p>
                   </a:txBody>
-                  <a:tcPr/>
+                  <a:tcPr>
+                    <a:solidFill>
+                      <a:srgbClr val="EBF5FB"/>
+                    </a:solidFill>
+                  </a:tcPr>
                 </a:tc>
                 <a:tc>
                   <a:txBody>
@@ -5231,11 +5466,15 @@
                         </a:defRPr>
                       </a:pPr>
                       <a:r>
-                        <a:t>Ragged mask edges</a:t>
+                        <a:t>Ragged mask edges (+/-1px)</a:t>
                       </a:r>
                     </a:p>
                   </a:txBody>
-                  <a:tcPr/>
+                  <a:tcPr>
+                    <a:solidFill>
+                      <a:srgbClr val="EBF5FB"/>
+                    </a:solidFill>
+                  </a:tcPr>
                 </a:tc>
                 <a:tc>
                   <a:txBody>
@@ -5254,7 +5493,11 @@
                       </a:r>
                     </a:p>
                   </a:txBody>
-                  <a:tcPr/>
+                  <a:tcPr>
+                    <a:solidFill>
+                      <a:srgbClr val="EBF5FB"/>
+                    </a:solidFill>
+                  </a:tcPr>
                 </a:tc>
               </a:tr>
             </a:tbl>
@@ -5285,46 +5528,46 @@
           <a:p>
             <a:pPr>
               <a:spcAft>
-                <a:spcPts val="800"/>
+                <a:spcPts val="600"/>
               </a:spcAft>
-              <a:defRPr sz="1400">
+              <a:defRPr sz="1500">
                 <a:solidFill>
                   <a:srgbClr val="333333"/>
                 </a:solidFill>
               </a:defRPr>
             </a:pPr>
             <a:r>
-              <a:t>JPEG artifacts affect 95.6% of masks; threshold &gt;=200 eliminates most</a:t>
+              <a:t>Production-ready for: lakes, large rivers, reservoirs</a:t>
             </a:r>
           </a:p>
           <a:p>
             <a:pPr>
               <a:spcAft>
-                <a:spcPts val="800"/>
+                <a:spcPts val="600"/>
               </a:spcAft>
-              <a:defRPr sz="1400">
+              <a:defRPr sz="1500">
                 <a:solidFill>
                   <a:srgbClr val="333333"/>
                 </a:solidFill>
               </a:defRPr>
             </a:pPr>
             <a:r>
-              <a:t>RGB-only is the biggest accuracy bottleneck -- NIR band would help most</a:t>
+              <a:t>Not suitable for: narrow canals, small ponds (&lt;500 m2), shadow-prone terrain</a:t>
             </a:r>
           </a:p>
           <a:p>
             <a:pPr>
               <a:spcAft>
-                <a:spcPts val="800"/>
+                <a:spcPts val="600"/>
               </a:spcAft>
-              <a:defRPr sz="1400">
+              <a:defRPr sz="1500">
                 <a:solidFill>
                   <a:srgbClr val="333333"/>
                 </a:solidFill>
               </a:defRPr>
             </a:pPr>
             <a:r>
-              <a:t>Failure modes are systematic and predictable, not random noise</a:t>
+              <a:t>Biggest bottleneck: RGB-only input -- adding NIR band would give +5-10% IOU</a:t>
             </a:r>
           </a:p>
         </p:txBody>
@@ -5340,6 +5583,14 @@
 <file path=ppt/slides/slide7.xml><?xml version="1.0" encoding="utf-8"?>
 <p:sld xmlns:a="http://schemas.openxmlformats.org/drawingml/2006/main" xmlns:p="http://schemas.openxmlformats.org/presentationml/2006/main" xmlns:r="http://schemas.openxmlformats.org/officeDocument/2006/relationships">
   <p:cSld>
+    <p:bg>
+      <p:bgPr>
+        <a:solidFill>
+          <a:srgbClr val="F5F7FA"/>
+        </a:solidFill>
+        <a:effectLst/>
+      </p:bgPr>
+    </p:bg>
     <p:spTree>
       <p:nvGrpSpPr>
         <p:cNvPr id="1" name=""/>
@@ -5364,20 +5615,20 @@
           <a:noFill/>
         </p:spPr>
         <p:txBody>
-          <a:bodyPr wrap="none">
+          <a:bodyPr wrap="square">
             <a:spAutoFit/>
           </a:bodyPr>
           <a:lstStyle/>
           <a:p>
-            <a:pPr>
+            <a:pPr algn="ctr">
               <a:defRPr sz="2800" b="1">
                 <a:solidFill>
-                  <a:srgbClr val="1B2A4A"/>
+                  <a:srgbClr val="333333"/>
                 </a:solidFill>
               </a:defRPr>
             </a:pPr>
             <a:r>
-              <a:t>MLOps &amp; Deployment</a:t>
+              <a:t>MLOps Pipeline</a:t>
             </a:r>
           </a:p>
         </p:txBody>
@@ -5390,7 +5641,85 @@
         </p:nvSpPr>
         <p:spPr>
           <a:xfrm>
-            <a:off x="731520" y="1371600"/>
+            <a:off x="914400" y="1188720"/>
+            <a:ext cx="10362895" cy="731520"/>
+          </a:xfrm>
+          <a:prstGeom prst="rect">
+            <a:avLst/>
+          </a:prstGeom>
+          <a:noFill/>
+        </p:spPr>
+        <p:txBody>
+          <a:bodyPr wrap="square">
+            <a:spAutoFit/>
+          </a:bodyPr>
+          <a:lstStyle/>
+          <a:p>
+            <a:pPr algn="ctr">
+              <a:defRPr sz="1600" b="1">
+                <a:solidFill>
+                  <a:srgbClr val="2E86AB"/>
+                </a:solidFill>
+              </a:defRPr>
+            </a:pPr>
+            <a:r>
+              <a:t>Git Push  -&gt;  Flake8 Lint  -&gt;  15 Pytest  -&gt;  Docker Build  -&gt;  Docker Hub Push</a:t>
+            </a:r>
+          </a:p>
+        </p:txBody>
+      </p:sp>
+      <p:sp>
+        <p:nvSpPr>
+          <p:cNvPr id="4" name="Rectangle 3"/>
+          <p:cNvSpPr/>
+          <p:nvPr/>
+        </p:nvSpPr>
+        <p:spPr>
+          <a:xfrm>
+            <a:off x="731520" y="2286000"/>
+            <a:ext cx="10515600" cy="27432"/>
+          </a:xfrm>
+          <a:prstGeom prst="rect">
+            <a:avLst/>
+          </a:prstGeom>
+          <a:solidFill>
+            <a:srgbClr val="2E86AB"/>
+          </a:solidFill>
+          <a:ln>
+            <a:noFill/>
+          </a:ln>
+        </p:spPr>
+        <p:style>
+          <a:lnRef idx="1">
+            <a:schemeClr val="accent1"/>
+          </a:lnRef>
+          <a:fillRef idx="3">
+            <a:schemeClr val="accent1"/>
+          </a:fillRef>
+          <a:effectRef idx="2">
+            <a:schemeClr val="accent1"/>
+          </a:effectRef>
+          <a:fontRef idx="minor">
+            <a:schemeClr val="lt1"/>
+          </a:fontRef>
+        </p:style>
+        <p:txBody>
+          <a:bodyPr rtlCol="0" anchor="ctr"/>
+          <a:lstStyle/>
+          <a:p>
+            <a:pPr algn="ctr"/>
+          </a:p>
+        </p:txBody>
+      </p:sp>
+      <p:sp>
+        <p:nvSpPr>
+          <p:cNvPr id="5" name="TextBox 4"/>
+          <p:cNvSpPr txBox="1"/>
+          <p:nvPr/>
+        </p:nvSpPr>
+        <p:spPr>
+          <a:xfrm>
+            <a:off x="731520" y="2560320"/>
             <a:ext cx="10515600" cy="4572000"/>
           </a:xfrm>
           <a:prstGeom prst="rect">
@@ -5406,7 +5735,7 @@
           <a:p>
             <a:pPr>
               <a:spcAft>
-                <a:spcPts val="800"/>
+                <a:spcPts val="600"/>
               </a:spcAft>
               <a:defRPr sz="1600">
                 <a:solidFill>
@@ -5415,13 +5744,13 @@
               </a:defRPr>
             </a:pPr>
             <a:r>
-              <a:t>Version Control: Git + Git LFS (model.onnx, 97 MB); .gitignore for artifacts</a:t>
+              <a:t>Docker: multi-stage build, ONNX baked in, HEALTHCHECK every 10s</a:t>
             </a:r>
           </a:p>
           <a:p>
             <a:pPr>
               <a:spcAft>
-                <a:spcPts val="800"/>
+                <a:spcPts val="600"/>
               </a:spcAft>
               <a:defRPr sz="1600">
                 <a:solidFill>
@@ -5430,13 +5759,13 @@
               </a:defRPr>
             </a:pPr>
             <a:r>
-              <a:t>Experiment Tracking: MLflow logs params, metrics, model artifacts per run</a:t>
+              <a:t>MLflow: per-epoch metrics, model registry (water-segmentation-unet v1)</a:t>
             </a:r>
           </a:p>
           <a:p>
             <a:pPr>
               <a:spcAft>
-                <a:spcPts val="800"/>
+                <a:spcPts val="600"/>
               </a:spcAft>
               <a:defRPr sz="1600">
                 <a:solidFill>
@@ -5445,13 +5774,13 @@
               </a:defRPr>
             </a:pPr>
             <a:r>
-              <a:t>Model Registry: 'water-segmentation-unet' v1 with serialization_format=pt2</a:t>
+              <a:t>Security: 60 req/min rate limiter, 100 MB cap, path traversal protection</a:t>
             </a:r>
           </a:p>
           <a:p>
             <a:pPr>
               <a:spcAft>
-                <a:spcPts val="800"/>
+                <a:spcPts val="600"/>
               </a:spcAft>
               <a:defRPr sz="1600">
                 <a:solidFill>
@@ -5460,13 +5789,13 @@
               </a:defRPr>
             </a:pPr>
             <a:r>
-              <a:t>Data Versioning: SHA256 dataset hash logged with each training run</a:t>
+              <a:t>Docker Hub: angelgupta/water-segmentation:latest</a:t>
             </a:r>
           </a:p>
           <a:p>
             <a:pPr>
               <a:spcAft>
-                <a:spcPts val="800"/>
+                <a:spcPts val="600"/>
               </a:spcAft>
               <a:defRPr sz="1600">
                 <a:solidFill>
@@ -5474,134 +5803,8 @@
                 </a:solidFill>
               </a:defRPr>
             </a:pPr>
-          </a:p>
-          <a:p>
-            <a:pPr>
-              <a:spcAft>
-                <a:spcPts val="800"/>
-              </a:spcAft>
-              <a:defRPr sz="1600">
-                <a:solidFill>
-                  <a:srgbClr val="333333"/>
-                </a:solidFill>
-              </a:defRPr>
-            </a:pPr>
-            <a:r>
-              <a:t>CI/CD (GitHub Actions):</a:t>
-            </a:r>
-          </a:p>
-          <a:p>
-            <a:pPr lvl="1">
-              <a:spcAft>
-                <a:spcPts val="800"/>
-              </a:spcAft>
-              <a:defRPr sz="1400">
-                <a:solidFill>
-                  <a:srgbClr val="606060"/>
-                </a:solidFill>
-              </a:defRPr>
-            </a:pPr>
-            <a:r>
-              <a:t>  Push -&gt; flake8 lint -&gt; 15 pytest -&gt; Docker build -&gt; Docker Hub push</a:t>
-            </a:r>
-          </a:p>
-          <a:p>
-            <a:pPr>
-              <a:spcAft>
-                <a:spcPts val="800"/>
-              </a:spcAft>
-              <a:defRPr sz="1600">
-                <a:solidFill>
-                  <a:srgbClr val="333333"/>
-                </a:solidFill>
-              </a:defRPr>
-            </a:pPr>
-          </a:p>
-          <a:p>
-            <a:pPr>
-              <a:spcAft>
-                <a:spcPts val="800"/>
-              </a:spcAft>
-              <a:defRPr sz="1600">
-                <a:solidFill>
-                  <a:srgbClr val="333333"/>
-                </a:solidFill>
-              </a:defRPr>
-            </a:pPr>
-            <a:r>
-              <a:t>Containerization:</a:t>
-            </a:r>
-          </a:p>
-          <a:p>
-            <a:pPr lvl="1">
-              <a:spcAft>
-                <a:spcPts val="800"/>
-              </a:spcAft>
-              <a:defRPr sz="1400">
-                <a:solidFill>
-                  <a:srgbClr val="606060"/>
-                </a:solidFill>
-              </a:defRPr>
-            </a:pPr>
-            <a:r>
-              <a:t>  Multi-stage Docker build, ONNX model baked in, HEALTHCHECK every 10s</a:t>
-            </a:r>
-          </a:p>
-          <a:p>
-            <a:pPr lvl="1">
-              <a:spcAft>
-                <a:spcPts val="800"/>
-              </a:spcAft>
-              <a:defRPr sz="1400">
-                <a:solidFill>
-                  <a:srgbClr val="606060"/>
-                </a:solidFill>
-              </a:defRPr>
-            </a:pPr>
-            <a:r>
-              <a:t>  docker-compose with API + MLflow server services</a:t>
-            </a:r>
-          </a:p>
-          <a:p>
-            <a:pPr>
-              <a:spcAft>
-                <a:spcPts val="800"/>
-              </a:spcAft>
-              <a:defRPr sz="1600">
-                <a:solidFill>
-                  <a:srgbClr val="333333"/>
-                </a:solidFill>
-              </a:defRPr>
-            </a:pPr>
-          </a:p>
-          <a:p>
-            <a:pPr>
-              <a:spcAft>
-                <a:spcPts val="800"/>
-              </a:spcAft>
-              <a:defRPr sz="1600">
-                <a:solidFill>
-                  <a:srgbClr val="333333"/>
-                </a:solidFill>
-              </a:defRPr>
-            </a:pPr>
-            <a:r>
-              <a:t>Security: path traversal protection, 100 MB upload cap,</a:t>
-            </a:r>
-          </a:p>
-          <a:p>
-            <a:pPr lvl="1">
-              <a:spcAft>
-                <a:spcPts val="800"/>
-              </a:spcAft>
-              <a:defRPr sz="1400">
-                <a:solidFill>
-                  <a:srgbClr val="606060"/>
-                </a:solidFill>
-              </a:defRPr>
-            </a:pPr>
-            <a:r>
-              <a:t>  60 req/min/IP rate limiter, thread-safe model cache</a:t>
+            <a:r>
+              <a:t>docker-compose: API server + MLflow tracking server</a:t>
             </a:r>
           </a:p>
         </p:txBody>
@@ -5617,6 +5820,14 @@
 <file path=ppt/slides/slide8.xml><?xml version="1.0" encoding="utf-8"?>
 <p:sld xmlns:a="http://schemas.openxmlformats.org/drawingml/2006/main" xmlns:p="http://schemas.openxmlformats.org/presentationml/2006/main" xmlns:r="http://schemas.openxmlformats.org/officeDocument/2006/relationships">
   <p:cSld>
+    <p:bg>
+      <p:bgPr>
+        <a:solidFill>
+          <a:srgbClr val="F5F7FA"/>
+        </a:solidFill>
+        <a:effectLst/>
+      </p:bgPr>
+    </p:bg>
     <p:spTree>
       <p:nvGrpSpPr>
         <p:cNvPr id="1" name=""/>
@@ -5641,15 +5852,15 @@
           <a:noFill/>
         </p:spPr>
         <p:txBody>
-          <a:bodyPr wrap="none">
+          <a:bodyPr wrap="square">
             <a:spAutoFit/>
           </a:bodyPr>
           <a:lstStyle/>
           <a:p>
-            <a:pPr>
+            <a:pPr algn="ctr">
               <a:defRPr sz="2800" b="1">
                 <a:solidFill>
-                  <a:srgbClr val="1B2A4A"/>
+                  <a:srgbClr val="333333"/>
                 </a:solidFill>
               </a:defRPr>
             </a:pPr>
@@ -5661,13 +5872,91 @@
       </p:sp>
       <p:sp>
         <p:nvSpPr>
-          <p:cNvPr id="3" name="TextBox 2"/>
+          <p:cNvPr id="3" name="Rectangle 2"/>
+          <p:cNvSpPr/>
+          <p:nvPr/>
+        </p:nvSpPr>
+        <p:spPr>
+          <a:xfrm>
+            <a:off x="548640" y="1188720"/>
+            <a:ext cx="3474720" cy="457200"/>
+          </a:xfrm>
+          <a:prstGeom prst="rect">
+            <a:avLst/>
+          </a:prstGeom>
+          <a:solidFill>
+            <a:srgbClr val="1B2A4A"/>
+          </a:solidFill>
+          <a:ln>
+            <a:noFill/>
+          </a:ln>
+        </p:spPr>
+        <p:style>
+          <a:lnRef idx="1">
+            <a:schemeClr val="accent1"/>
+          </a:lnRef>
+          <a:fillRef idx="3">
+            <a:schemeClr val="accent1"/>
+          </a:fillRef>
+          <a:effectRef idx="2">
+            <a:schemeClr val="accent1"/>
+          </a:effectRef>
+          <a:fontRef idx="minor">
+            <a:schemeClr val="lt1"/>
+          </a:fontRef>
+        </p:style>
+        <p:txBody>
+          <a:bodyPr rtlCol="0" anchor="ctr"/>
+          <a:lstStyle/>
+          <a:p>
+            <a:pPr algn="ctr"/>
+          </a:p>
+        </p:txBody>
+      </p:sp>
+      <p:sp>
+        <p:nvSpPr>
+          <p:cNvPr id="4" name="TextBox 3"/>
           <p:cNvSpPr txBox="1"/>
           <p:nvPr/>
         </p:nvSpPr>
         <p:spPr>
           <a:xfrm>
-            <a:off x="731520" y="1371600"/>
+            <a:off x="548640" y="1188720"/>
+            <a:ext cx="3474720" cy="731520"/>
+          </a:xfrm>
+          <a:prstGeom prst="rect">
+            <a:avLst/>
+          </a:prstGeom>
+          <a:noFill/>
+        </p:spPr>
+        <p:txBody>
+          <a:bodyPr wrap="square">
+            <a:spAutoFit/>
+          </a:bodyPr>
+          <a:lstStyle/>
+          <a:p>
+            <a:pPr algn="ctr">
+              <a:defRPr sz="1400" b="1">
+                <a:solidFill>
+                  <a:srgbClr val="FFFFFF"/>
+                </a:solidFill>
+              </a:defRPr>
+            </a:pPr>
+            <a:r>
+              <a:t>HIGH IMPACT (+5-10% IOU)</a:t>
+            </a:r>
+          </a:p>
+        </p:txBody>
+      </p:sp>
+      <p:sp>
+        <p:nvSpPr>
+          <p:cNvPr id="5" name="TextBox 4"/>
+          <p:cNvSpPr txBox="1"/>
+          <p:nvPr/>
+        </p:nvSpPr>
+        <p:spPr>
+          <a:xfrm>
+            <a:off x="548640" y="1828800"/>
             <a:ext cx="10515600" cy="4572000"/>
           </a:xfrm>
           <a:prstGeom prst="rect">
@@ -5683,163 +5972,363 @@
           <a:p>
             <a:pPr>
               <a:spcAft>
-                <a:spcPts val="800"/>
+                <a:spcPts val="600"/>
               </a:spcAft>
-              <a:defRPr sz="1600">
+              <a:defRPr sz="1500">
                 <a:solidFill>
                   <a:srgbClr val="333333"/>
                 </a:solidFill>
               </a:defRPr>
             </a:pPr>
             <a:r>
-              <a:t>1. Train on full-resolution crops (not resized) -- expected +5-8% IOU</a:t>
+              <a:t>Add NIR band input (Band 8)</a:t>
             </a:r>
           </a:p>
           <a:p>
             <a:pPr>
               <a:spcAft>
-                <a:spcPts val="800"/>
+                <a:spcPts val="600"/>
               </a:spcAft>
-              <a:defRPr sz="1600">
+              <a:defRPr sz="1500">
                 <a:solidFill>
                   <a:srgbClr val="333333"/>
                 </a:solidFill>
               </a:defRPr>
             </a:pPr>
             <a:r>
-              <a:t>2. Add NIR band input -- single biggest expected gain (+5-10% IOU)</a:t>
-            </a:r>
-          </a:p>
+              <a:t>Train on full-resolution crops</a:t>
+            </a:r>
+          </a:p>
+        </p:txBody>
+      </p:sp>
+      <p:sp>
+        <p:nvSpPr>
+          <p:cNvPr id="6" name="Rectangle 5"/>
+          <p:cNvSpPr/>
+          <p:nvPr/>
+        </p:nvSpPr>
+        <p:spPr>
+          <a:xfrm>
+            <a:off x="4389120" y="1188720"/>
+            <a:ext cx="3474720" cy="457200"/>
+          </a:xfrm>
+          <a:prstGeom prst="rect">
+            <a:avLst/>
+          </a:prstGeom>
+          <a:solidFill>
+            <a:srgbClr val="2E86AB"/>
+          </a:solidFill>
+          <a:ln>
+            <a:noFill/>
+          </a:ln>
+        </p:spPr>
+        <p:style>
+          <a:lnRef idx="1">
+            <a:schemeClr val="accent1"/>
+          </a:lnRef>
+          <a:fillRef idx="3">
+            <a:schemeClr val="accent1"/>
+          </a:fillRef>
+          <a:effectRef idx="2">
+            <a:schemeClr val="accent1"/>
+          </a:effectRef>
+          <a:fontRef idx="minor">
+            <a:schemeClr val="lt1"/>
+          </a:fontRef>
+        </p:style>
+        <p:txBody>
+          <a:bodyPr rtlCol="0" anchor="ctr"/>
+          <a:lstStyle/>
+          <a:p>
+            <a:pPr algn="ctr"/>
+          </a:p>
+        </p:txBody>
+      </p:sp>
+      <p:sp>
+        <p:nvSpPr>
+          <p:cNvPr id="7" name="TextBox 6"/>
+          <p:cNvSpPr txBox="1"/>
+          <p:nvPr/>
+        </p:nvSpPr>
+        <p:spPr>
+          <a:xfrm>
+            <a:off x="4389120" y="1188720"/>
+            <a:ext cx="3474720" cy="731520"/>
+          </a:xfrm>
+          <a:prstGeom prst="rect">
+            <a:avLst/>
+          </a:prstGeom>
+          <a:noFill/>
+        </p:spPr>
+        <p:txBody>
+          <a:bodyPr wrap="square">
+            <a:spAutoFit/>
+          </a:bodyPr>
+          <a:lstStyle/>
+          <a:p>
+            <a:pPr algn="ctr">
+              <a:defRPr sz="1400" b="1">
+                <a:solidFill>
+                  <a:srgbClr val="FFFFFF"/>
+                </a:solidFill>
+              </a:defRPr>
+            </a:pPr>
+            <a:r>
+              <a:t>MEDIUM IMPACT (+1-3% IOU)</a:t>
+            </a:r>
+          </a:p>
+        </p:txBody>
+      </p:sp>
+      <p:sp>
+        <p:nvSpPr>
+          <p:cNvPr id="8" name="TextBox 7"/>
+          <p:cNvSpPr txBox="1"/>
+          <p:nvPr/>
+        </p:nvSpPr>
+        <p:spPr>
+          <a:xfrm>
+            <a:off x="4389120" y="1828800"/>
+            <a:ext cx="10515600" cy="4572000"/>
+          </a:xfrm>
+          <a:prstGeom prst="rect">
+            <a:avLst/>
+          </a:prstGeom>
+          <a:noFill/>
+        </p:spPr>
+        <p:txBody>
+          <a:bodyPr wrap="square">
+            <a:spAutoFit/>
+          </a:bodyPr>
+          <a:lstStyle/>
           <a:p>
             <a:pPr>
               <a:spcAft>
-                <a:spcPts val="800"/>
+                <a:spcPts val="600"/>
               </a:spcAft>
-              <a:defRPr sz="1600">
+              <a:defRPr sz="1500">
                 <a:solidFill>
                   <a:srgbClr val="333333"/>
                 </a:solidFill>
               </a:defRPr>
             </a:pPr>
             <a:r>
-              <a:t>3. EfficientNet-B4 encoder -- higher capacity, +2-3% IOU</a:t>
+              <a:t>EfficientNet-B4 encoder</a:t>
             </a:r>
           </a:p>
           <a:p>
             <a:pPr>
               <a:spcAft>
-                <a:spcPts val="800"/>
+                <a:spcPts val="600"/>
               </a:spcAft>
-              <a:defRPr sz="1600">
+              <a:defRPr sz="1500">
                 <a:solidFill>
                   <a:srgbClr val="333333"/>
                 </a:solidFill>
               </a:defRPr>
             </a:pPr>
             <a:r>
-              <a:t>4. CRF post-processing -- sharpen boundaries, fix JPEG edge noise</a:t>
-            </a:r>
-          </a:p>
+              <a:t>Optuna Bayesian search (30+ trials)</a:t>
+            </a:r>
+          </a:p>
+        </p:txBody>
+      </p:sp>
+      <p:sp>
+        <p:nvSpPr>
+          <p:cNvPr id="9" name="Rectangle 8"/>
+          <p:cNvSpPr/>
+          <p:nvPr/>
+        </p:nvSpPr>
+        <p:spPr>
+          <a:xfrm>
+            <a:off x="8229600" y="1188720"/>
+            <a:ext cx="3474720" cy="457200"/>
+          </a:xfrm>
+          <a:prstGeom prst="rect">
+            <a:avLst/>
+          </a:prstGeom>
+          <a:solidFill>
+            <a:srgbClr val="808080"/>
+          </a:solidFill>
+          <a:ln>
+            <a:noFill/>
+          </a:ln>
+        </p:spPr>
+        <p:style>
+          <a:lnRef idx="1">
+            <a:schemeClr val="accent1"/>
+          </a:lnRef>
+          <a:fillRef idx="3">
+            <a:schemeClr val="accent1"/>
+          </a:fillRef>
+          <a:effectRef idx="2">
+            <a:schemeClr val="accent1"/>
+          </a:effectRef>
+          <a:fontRef idx="minor">
+            <a:schemeClr val="lt1"/>
+          </a:fontRef>
+        </p:style>
+        <p:txBody>
+          <a:bodyPr rtlCol="0" anchor="ctr"/>
+          <a:lstStyle/>
+          <a:p>
+            <a:pPr algn="ctr"/>
+          </a:p>
+        </p:txBody>
+      </p:sp>
+      <p:sp>
+        <p:nvSpPr>
+          <p:cNvPr id="10" name="TextBox 9"/>
+          <p:cNvSpPr txBox="1"/>
+          <p:nvPr/>
+        </p:nvSpPr>
+        <p:spPr>
+          <a:xfrm>
+            <a:off x="8229600" y="1188720"/>
+            <a:ext cx="3474720" cy="731520"/>
+          </a:xfrm>
+          <a:prstGeom prst="rect">
+            <a:avLst/>
+          </a:prstGeom>
+          <a:noFill/>
+        </p:spPr>
+        <p:txBody>
+          <a:bodyPr wrap="square">
+            <a:spAutoFit/>
+          </a:bodyPr>
+          <a:lstStyle/>
+          <a:p>
+            <a:pPr algn="ctr">
+              <a:defRPr sz="1400" b="1">
+                <a:solidFill>
+                  <a:srgbClr val="FFFFFF"/>
+                </a:solidFill>
+              </a:defRPr>
+            </a:pPr>
+            <a:r>
+              <a:t>LOW IMPACT (+0.5-1% IOU)</a:t>
+            </a:r>
+          </a:p>
+        </p:txBody>
+      </p:sp>
+      <p:sp>
+        <p:nvSpPr>
+          <p:cNvPr id="11" name="TextBox 10"/>
+          <p:cNvSpPr txBox="1"/>
+          <p:nvPr/>
+        </p:nvSpPr>
+        <p:spPr>
+          <a:xfrm>
+            <a:off x="8229600" y="1828800"/>
+            <a:ext cx="10515600" cy="4572000"/>
+          </a:xfrm>
+          <a:prstGeom prst="rect">
+            <a:avLst/>
+          </a:prstGeom>
+          <a:noFill/>
+        </p:spPr>
+        <p:txBody>
+          <a:bodyPr wrap="square">
+            <a:spAutoFit/>
+          </a:bodyPr>
+          <a:lstStyle/>
           <a:p>
             <a:pPr>
               <a:spcAft>
-                <a:spcPts val="800"/>
+                <a:spcPts val="600"/>
               </a:spcAft>
-              <a:defRPr sz="1600">
+              <a:defRPr sz="1500">
                 <a:solidFill>
                   <a:srgbClr val="333333"/>
                 </a:solidFill>
               </a:defRPr>
             </a:pPr>
             <a:r>
-              <a:t>5. Optuna Bayesian search -- replace grid with 30+ trial optimization</a:t>
+              <a:t>Ensemble (3-5 seeds)</a:t>
             </a:r>
           </a:p>
           <a:p>
             <a:pPr>
               <a:spcAft>
-                <a:spcPts val="800"/>
+                <a:spcPts val="600"/>
               </a:spcAft>
-              <a:defRPr sz="1600">
+              <a:defRPr sz="1500">
                 <a:solidFill>
                   <a:srgbClr val="333333"/>
                 </a:solidFill>
               </a:defRPr>
             </a:pPr>
             <a:r>
-              <a:t>6. Ensemble 3-5 runs -- reduce variance, +1-2% IOU</a:t>
-            </a:r>
-          </a:p>
-          <a:p>
-            <a:pPr>
-              <a:spcAft>
-                <a:spcPts val="800"/>
-              </a:spcAft>
-              <a:defRPr sz="1600">
+              <a:t>CRF post-processing</a:t>
+            </a:r>
+          </a:p>
+        </p:txBody>
+      </p:sp>
+      <p:sp>
+        <p:nvSpPr>
+          <p:cNvPr id="12" name="TextBox 11"/>
+          <p:cNvSpPr txBox="1"/>
+          <p:nvPr/>
+        </p:nvSpPr>
+        <p:spPr>
+          <a:xfrm>
+            <a:off x="914400" y="3657600"/>
+            <a:ext cx="10362895" cy="731520"/>
+          </a:xfrm>
+          <a:prstGeom prst="rect">
+            <a:avLst/>
+          </a:prstGeom>
+          <a:noFill/>
+        </p:spPr>
+        <p:txBody>
+          <a:bodyPr wrap="square">
+            <a:spAutoFit/>
+          </a:bodyPr>
+          <a:lstStyle/>
+          <a:p>
+            <a:pPr algn="ctr">
+              <a:defRPr sz="1800" b="0">
                 <a:solidFill>
                   <a:srgbClr val="333333"/>
                 </a:solidFill>
               </a:defRPr>
             </a:pPr>
-          </a:p>
-          <a:p>
-            <a:pPr>
-              <a:spcAft>
-                <a:spcPts val="800"/>
-              </a:spcAft>
-              <a:defRPr sz="1600">
-                <a:solidFill>
-                  <a:srgbClr val="333333"/>
+            <a:r>
+              <a:t>Current model (IOU 0.82) is production-ready for coarse water mapping.</a:t>
+            </a:r>
+          </a:p>
+        </p:txBody>
+      </p:sp>
+      <p:sp>
+        <p:nvSpPr>
+          <p:cNvPr id="13" name="TextBox 12"/>
+          <p:cNvSpPr txBox="1"/>
+          <p:nvPr/>
+        </p:nvSpPr>
+        <p:spPr>
+          <a:xfrm>
+            <a:off x="914400" y="4389120"/>
+            <a:ext cx="10362895" cy="731520"/>
+          </a:xfrm>
+          <a:prstGeom prst="rect">
+            <a:avLst/>
+          </a:prstGeom>
+          <a:noFill/>
+        </p:spPr>
+        <p:txBody>
+          <a:bodyPr wrap="square">
+            <a:spAutoFit/>
+          </a:bodyPr>
+          <a:lstStyle/>
+          <a:p>
+            <a:pPr algn="ctr">
+              <a:defRPr sz="1800" b="0">
+                <a:solidFill>
+                  <a:srgbClr val="808080"/>
                 </a:solidFill>
               </a:defRPr>
             </a:pPr>
             <a:r>
-              <a:t>Key Takeaway:</a:t>
-            </a:r>
-          </a:p>
-          <a:p>
-            <a:pPr lvl="1">
-              <a:spcAft>
-                <a:spcPts val="800"/>
-              </a:spcAft>
-              <a:defRPr sz="1400">
-                <a:solidFill>
-                  <a:srgbClr val="606060"/>
-                </a:solidFill>
-              </a:defRPr>
-            </a:pPr>
-            <a:r>
-              <a:t>  The current model (IOU 0.82 test) is production-ready for coarse</a:t>
-            </a:r>
-          </a:p>
-          <a:p>
-            <a:pPr lvl="1">
-              <a:spcAft>
-                <a:spcPts val="800"/>
-              </a:spcAft>
-              <a:defRPr sz="1400">
-                <a:solidFill>
-                  <a:srgbClr val="606060"/>
-                </a:solidFill>
-              </a:defRPr>
-            </a:pPr>
-            <a:r>
-              <a:t>  water mapping. Adding NIR and full-resolution training would close</a:t>
-            </a:r>
-          </a:p>
-          <a:p>
-            <a:pPr lvl="1">
-              <a:spcAft>
-                <a:spcPts val="800"/>
-              </a:spcAft>
-              <a:defRPr sz="1400">
-                <a:solidFill>
-                  <a:srgbClr val="606060"/>
-                </a:solidFill>
-              </a:defRPr>
-            </a:pPr>
-            <a:r>
-              <a:t>  the gap to high-precision applications.</a:t>
+              <a:t>Adding NIR band and full-resolution training would close the gap to high-precision applications.</a:t>
             </a:r>
           </a:p>
         </p:txBody>

</xml_diff>